<commit_message>
Update Viper deck with Josh's accuracy corrections
Dispatched-appointments definition (DQ + verified homeowner no-show excluded; rep no-show and door cancel still count), self-gen+referral metric, level-playing-field pooling (region only, no sales channel), 180-day pull-through exemption surfaced, removed the now-invalid by-channel slide.

Co-Authored-By: Claude Opus 4.8 <noreply@anthropic.com>
</commit_message>
<xml_diff>
--- a/management/viper-ranking-overview.pptx
+++ b/management/viper-ranking-overview.pptx
@@ -19,7 +19,6 @@
     <p:sldId id="267" r:id="rId19"/>
     <p:sldId id="268" r:id="rId20"/>
     <p:sldId id="269" r:id="rId21"/>
-    <p:sldId id="270" r:id="rId22"/>
   </p:sldIdLst>
   <p:sldSz cx="12191695" cy="6858000" type="screen4x3"/>
   <p:notesSz cx="6858000" cy="9144000"/>
@@ -656,7 +655,7 @@
           <a:lstStyle/>
           <a:p>
             <a:r>
-              <a:t>How your score becomes your rank. Inside your pool, your region and division, the highest scores earn the highest ranks. A rep who works several regions keeps the best rank they earn. It rebalances weekly, so a 4 means the same thing across the company. For example, a 79 lands in the rank-4 tier.</a:t>
+              <a:t>How your score becomes your rank. Your pool is your region, no sales channel, everyone in the region together. Inside it, the highest scores earn the highest ranks. Regionals and above who cover several regions keep the best rank they earn. It rebalances weekly, so a 4 means the same thing across the company. For example, a 79 lands in the rank-4 tier.</a:t>
             </a:r>
           </a:p>
         </p:txBody>
@@ -726,7 +725,7 @@
           <a:lstStyle/>
           <a:p>
             <a:r>
-              <a:t>Every channel is scored with the same five measures, weights, and windows. Three things differ. One, the volume bar for a top rank: Direct needs 15 at-bats, Traditional 20, Inside Sales 30. Two, tenure counts from time on leads, which lines up with hire date for Traditional but not for Direct, whose path runs prime to graduate to director. Three, you're ranked inside your own channel and region, never across.</a:t>
+              <a:t>Guardrails. Most reps just earn their rank. A few get a floor or a cap. Hall of Fame, 1,000 or more career installs, is always a 5 and isn't counted in the rank-5 math. DM and above floor at 4. ADM, training, and assistant managers floor at 3. New hires floor at 3 for their first 40 appointments or 8 months. Low volume, too few at-bats for the channel, caps you at 4. Key point: a floor is a minimum, not a ceiling. Anyone can earn higher on merit; only Hall of Fame is automatic.</a:t>
             </a:r>
           </a:p>
         </p:txBody>
@@ -796,7 +795,7 @@
           <a:lstStyle/>
           <a:p>
             <a:r>
-              <a:t>Guardrails. Most reps just earn their rank. A few get a floor or a cap. Hall of Fame, 1,000 or more career installs, is always a 5 and isn't counted in the rank-5 math. DM and above floor at 4. ADM, training, and assistant managers floor at 3. New hires floor at 3 for their first 40 appointments or 8 months. Low volume, too few at-bats for the channel, caps you at 4. Key point: a floor is a minimum, not a ceiling. Anyone can earn higher on merit; only Hall of Fame is automatic.</a:t>
+              <a:t>A real rep from last week, name withheld. Effective rate 26 against a 30 target, so nearly maxed. Pull-through 78 against 80, also strong. Those two are 80 percent of the score, and being near target on both is what carries them. Attachment is only 4 against a 30 target, the clear gap. Pricing 79, self-gen 22. Run it through the weights and it lands at 79, a rank 4, up from a 3 the week before. The dates at the bottom are the actual windows from this run, the timelines from the earlier slide made concrete.</a:t>
             </a:r>
           </a:p>
         </p:txBody>
@@ -866,76 +865,6 @@
           <a:lstStyle/>
           <a:p>
             <a:r>
-              <a:t>A real rep from last week, name withheld. Effective rate 26 against a 30 target, so nearly maxed. Pull-through 78 against 80, also strong. Those two are 80 percent of the score, and being near target on both is what carries them. Attachment is only 4 against a 30 target, the clear gap. Pricing 79, self-gen 22. Run it through the weights and it lands at 79, a rank 4, up from a 3 the week before. The dates at the bottom are the actual windows from this run, the timelines from the earlier slide made concrete.</a:t>
-            </a:r>
-          </a:p>
-        </p:txBody>
-      </p:sp>
-      <p:sp>
-        <p:nvSpPr>
-          <p:cNvPr id="4" name="Slide Number Placeholder 3"/>
-          <p:cNvSpPr>
-            <a:spLocks noGrp="1"/>
-          </p:cNvSpPr>
-          <p:nvPr>
-            <p:ph type="sldNum" idx="5" sz="quarter"/>
-          </p:nvPr>
-        </p:nvSpPr>
-        <p:spPr/>
-      </p:sp>
-    </p:spTree>
-  </p:cSld>
-  <p:clrMapOvr>
-    <a:masterClrMapping/>
-  </p:clrMapOvr>
-</p:notes>
-</file>
-
-<file path=ppt/notesSlides/notesSlide15.xml><?xml version="1.0" encoding="utf-8"?>
-<p:notes xmlns:a="http://schemas.openxmlformats.org/drawingml/2006/main" xmlns:p="http://schemas.openxmlformats.org/presentationml/2006/main" xmlns:r="http://schemas.openxmlformats.org/officeDocument/2006/relationships">
-  <p:cSld>
-    <p:spTree>
-      <p:nvGrpSpPr>
-        <p:cNvPr id="1" name=""/>
-        <p:cNvGrpSpPr/>
-        <p:nvPr/>
-      </p:nvGrpSpPr>
-      <p:grpSpPr>
-        <a:xfrm>
-          <a:off x="0" y="0"/>
-          <a:ext cx="0" cy="0"/>
-          <a:chOff x="0" y="0"/>
-          <a:chExt cx="0" cy="0"/>
-        </a:xfrm>
-      </p:grpSpPr>
-      <p:sp>
-        <p:nvSpPr>
-          <p:cNvPr id="2" name="Slide Image Placeholder 1"/>
-          <p:cNvSpPr>
-            <a:spLocks noGrp="1"/>
-          </p:cNvSpPr>
-          <p:nvPr>
-            <p:ph type="sldImg" idx="2"/>
-          </p:nvPr>
-        </p:nvSpPr>
-        <p:spPr/>
-      </p:sp>
-      <p:sp>
-        <p:nvSpPr>
-          <p:cNvPr id="3" name="Notes Placeholder 2"/>
-          <p:cNvSpPr>
-            <a:spLocks noGrp="1"/>
-          </p:cNvSpPr>
-          <p:nvPr>
-            <p:ph type="body" idx="3" sz="quarter"/>
-          </p:nvPr>
-        </p:nvSpPr>
-        <p:spPr/>
-        <p:txBody>
-          <a:bodyPr/>
-          <a:lstStyle/>
-          <a:p>
-            <a:r>
               <a:t>Why the new system is steadier. Pull-through: a contract counts once its project has an install date, and ops moves those dates for delays, not cancellations, so a short window turned ops timing into score swings. A full year, with the last four months set aside, gives a true rate. Effective rate: we dropped the heavy 30-day, monthly-ranked approach for a 90-day average refreshed weekly, so a rough patch doesn't tank you and a real turnaround shows up fast. Weighting: close rate used to be nearly two-thirds of the score; now it's spread across five measures with floors for new and low-volume reps. And sit rate is no longer scored on its own. The result is more consistency and a fair, responsive path for reps to climb.</a:t>
             </a:r>
           </a:p>
@@ -1286,7 +1215,7 @@
           <a:lstStyle/>
           <a:p>
             <a:r>
-              <a:t>Each measure is a simple ratio, then scored against its own target and weighted. The target is the level that earns full marks: a 30 percent effective rate, for example, maxes that metric. Effective rate: approved contracts over the appointments we gave you. Pull-through: of the deals you signed, how many have an install date, tied per contract, not all installs over all contracts. Attachment: roof and battery add-ons over solar contracts, counted by category, so two batteries still count once. Pricing: contracts at target price over all contracts. Self-gen: your own deals over all your contracts.</a:t>
+              <a:t>Each measure is a simple ratio, then scored against its own target and weighted. The target is the level that earns full marks: a 30 percent effective rate, for example, maxes that metric. Effective rate: approved contracts over the appointments we gave you. Pull-through: of the deals you signed, how many have an install date, tied per contract, not all installs over all contracts. Attachment: roof and battery add-ons over solar contracts, counted by category, so two batteries still count once. Pricing: contracts at target price over all contracts. Self-gen: self-gen and referral deals over all your contracts.</a:t>
             </a:r>
           </a:p>
         </p:txBody>
@@ -1496,7 +1425,7 @@
           <a:lstStyle/>
           <a:p>
             <a:r>
-              <a:t>Three ground rules before the timelines. One, company leads only: the score is about what we hand you; self-gen only matters for its own 5 percent. Two, a strike is a real at-bat, an appointment where someone was home; no-shows and disqualified leads, DQs, are pulled out so they don't help or hurt. Three, you're measured inside your own division and region, so it's apples to apples.</a:t>
+              <a:t>Three ground rules. One, company leads only: the score is about what we hand you; self-gen and referral only matter for their own 5 percent. Two, dispatched appointments: every appointment we gave you, minus DQs and verified homeowner no-shows. A rep no-show or a cancel at the door still counts against the rep. Three, it's a level playing field. Viper removed the lanes, so you're ranked against every rep in the regions you run, regardless of sales channel.</a:t>
             </a:r>
           </a:p>
         </p:txBody>
@@ -5993,8 +5922,8 @@
         </p:nvSpPr>
         <p:spPr>
           <a:xfrm>
-            <a:off x="2743200" y="4434840"/>
-            <a:ext cx="8595360" cy="274320"/>
+            <a:off x="2743200" y="4398264"/>
+            <a:ext cx="8595360" cy="457200"/>
           </a:xfrm>
           <a:prstGeom prst="rect">
             <a:avLst/>
@@ -6007,7 +5936,11 @@
           </a:bodyPr>
           <a:lstStyle/>
           <a:p>
-            <a:pPr algn="l"/>
+            <a:pPr algn="l">
+              <a:spcAft>
+                <a:spcPts val="300"/>
+              </a:spcAft>
+            </a:pPr>
             <a:r>
               <a:rPr sz="1100" b="0">
                 <a:solidFill>
@@ -6015,7 +5948,23 @@
                 </a:solidFill>
                 <a:latin typeface="Segoe UI"/>
               </a:rPr>
-              <a:t>Grey = recent stretch we leave out.    Bars not to exact scale.</a:t>
+              <a:t>Grey = recent stretch we leave out. Bars not to exact scale.</a:t>
+            </a:r>
+          </a:p>
+          <a:p>
+            <a:pPr algn="l">
+              <a:spcAft>
+                <a:spcPts val="300"/>
+              </a:spcAft>
+            </a:pPr>
+            <a:r>
+              <a:rPr sz="1100" b="0">
+                <a:solidFill>
+                  <a:srgbClr val="5E665E"/>
+                </a:solidFill>
+                <a:latin typeface="Segoe UI"/>
+              </a:rPr>
+              <a:t>New reps (under 180 days on leads) are left out of pull-through entirely.</a:t>
             </a:r>
           </a:p>
         </p:txBody>
@@ -6442,7 +6391,7 @@
                 </a:solidFill>
                 <a:latin typeface="Segoe UI"/>
               </a:rPr>
-              <a:t>Inside your pool, the highest scores earn the highest ranks.</a:t>
+              <a:t>Inside your region pool, the highest scores earn the highest ranks. No sales channel, everyone in the region together.</a:t>
             </a:r>
           </a:p>
         </p:txBody>
@@ -6521,7 +6470,7 @@
                 </a:solidFill>
                 <a:latin typeface="Segoe UI"/>
               </a:rPr>
-              <a:t>Best rank wins across regions.  </a:t>
+              <a:t>Best rank across regions.  </a:t>
             </a:r>
             <a:r>
               <a:rPr sz="1500" b="0">
@@ -6530,7 +6479,7 @@
                 </a:solidFill>
                 <a:latin typeface="Segoe UI"/>
               </a:rPr>
-              <a:t>Work several regions and you keep the highest rank you earn.</a:t>
+              <a:t>Regionals and above who cover several regions keep the highest rank they earn.</a:t>
             </a:r>
           </a:p>
         </p:txBody>
@@ -6902,7 +6851,7 @@
                 </a:solidFill>
                 <a:latin typeface="Segoe UI"/>
               </a:rPr>
-              <a:t>By channel: same score, a few differences</a:t>
+              <a:t>Guardrails: floors and a cap</a:t>
             </a:r>
           </a:p>
         </p:txBody>
@@ -6937,7 +6886,7 @@
                 </a:solidFill>
                 <a:latin typeface="Segoe UI"/>
               </a:rPr>
-              <a:t>Direct, Traditional, and Inside Sales are scored the same way. Three things vary.</a:t>
+              <a:t>Most reps earn their rank outright. A few cases get a floor or a cap.</a:t>
             </a:r>
           </a:p>
         </p:txBody>
@@ -6950,8 +6899,8 @@
         </p:nvSpPr>
         <p:spPr>
           <a:xfrm>
-            <a:off x="640080" y="1874519"/>
-            <a:ext cx="10908792" cy="1234440"/>
+            <a:off x="640080" y="1810512"/>
+            <a:ext cx="10908792" cy="731520"/>
           </a:xfrm>
           <a:prstGeom prst="roundRect">
             <a:avLst/>
@@ -6990,20 +6939,64 @@
       </p:sp>
       <p:sp>
         <p:nvSpPr>
-          <p:cNvPr id="8" name="Rectangle 7"/>
+          <p:cNvPr id="8" name="TextBox 7"/>
+          <p:cNvSpPr txBox="1"/>
+          <p:nvPr/>
+        </p:nvSpPr>
+        <p:spPr>
+          <a:xfrm>
+            <a:off x="1005840" y="1810512"/>
+            <a:ext cx="8074151" cy="731520"/>
+          </a:xfrm>
+          <a:prstGeom prst="rect">
+            <a:avLst/>
+          </a:prstGeom>
+          <a:noFill/>
+        </p:spPr>
+        <p:txBody>
+          <a:bodyPr wrap="square" anchor="ctr" lIns="0" rIns="0" tIns="0" bIns="0">
+            <a:spAutoFit/>
+          </a:bodyPr>
+          <a:lstStyle/>
+          <a:p>
+            <a:pPr algn="l"/>
+            <a:r>
+              <a:rPr sz="1650" b="1">
+                <a:solidFill>
+                  <a:srgbClr val="1A2332"/>
+                </a:solidFill>
+                <a:latin typeface="Segoe UI"/>
+              </a:rPr>
+              <a:t>Hall of Fame    </a:t>
+            </a:r>
+            <a:r>
+              <a:rPr sz="1300" b="0">
+                <a:solidFill>
+                  <a:srgbClr val="5E665E"/>
+                </a:solidFill>
+                <a:latin typeface="Segoe UI"/>
+              </a:rPr>
+              <a:t>1,000+ career installs</a:t>
+            </a:r>
+          </a:p>
+        </p:txBody>
+      </p:sp>
+      <p:sp>
+        <p:nvSpPr>
+          <p:cNvPr id="9" name="Rounded Rectangle 8"/>
           <p:cNvSpPr/>
           <p:nvPr/>
         </p:nvSpPr>
         <p:spPr>
           <a:xfrm>
-            <a:off x="640080" y="1874519"/>
-            <a:ext cx="164592" cy="1234440"/>
-          </a:xfrm>
-          <a:prstGeom prst="rect">
+            <a:off x="9281159" y="1929384"/>
+            <a:ext cx="2103120" cy="493776"/>
+          </a:xfrm>
+          <a:prstGeom prst="roundRect">
             <a:avLst/>
           </a:prstGeom>
           <a:solidFill>
-            <a:srgbClr val="5EBA28"/>
+            <a:srgbClr val="4F9D28"/>
           </a:solidFill>
           <a:ln>
             <a:noFill/>
@@ -7034,14 +7027,14 @@
       </p:sp>
       <p:sp>
         <p:nvSpPr>
-          <p:cNvPr id="9" name="TextBox 8"/>
+          <p:cNvPr id="10" name="TextBox 9"/>
           <p:cNvSpPr txBox="1"/>
           <p:nvPr/>
         </p:nvSpPr>
         <p:spPr>
           <a:xfrm>
-            <a:off x="1143000" y="1874519"/>
-            <a:ext cx="10085832" cy="1234440"/>
+            <a:off x="9281159" y="1929384"/>
+            <a:ext cx="2103120" cy="493776"/>
           </a:xfrm>
           <a:prstGeom prst="rect">
             <a:avLst/>
@@ -7054,49 +7047,29 @@
           </a:bodyPr>
           <a:lstStyle/>
           <a:p>
-            <a:pPr algn="l">
-              <a:spcAft>
-                <a:spcPts val="700"/>
-              </a:spcAft>
-            </a:pPr>
-            <a:r>
-              <a:rPr sz="1800" b="1">
-                <a:solidFill>
-                  <a:srgbClr val="1A2332"/>
-                </a:solidFill>
-                <a:latin typeface="Segoe UI"/>
-              </a:rPr>
-              <a:t>Volume needed for a top rank</a:t>
-            </a:r>
-          </a:p>
-          <a:p>
-            <a:pPr algn="l">
-              <a:spcAft>
-                <a:spcPts val="700"/>
-              </a:spcAft>
-            </a:pPr>
-            <a:r>
-              <a:rPr sz="1450" b="0">
-                <a:solidFill>
-                  <a:srgbClr val="5E665E"/>
-                </a:solidFill>
-                <a:latin typeface="Segoe UI"/>
-              </a:rPr>
-              <a:t>At-bats over 90 days before you can earn a 5:  Direct 15,  Traditional 20,  Inside Sales 30.</a:t>
-            </a:r>
-          </a:p>
-        </p:txBody>
-      </p:sp>
-      <p:sp>
-        <p:nvSpPr>
-          <p:cNvPr id="10" name="Rounded Rectangle 9"/>
+            <a:pPr algn="ctr"/>
+            <a:r>
+              <a:rPr sz="1500" b="1">
+                <a:solidFill>
+                  <a:srgbClr val="FFFFFF"/>
+                </a:solidFill>
+                <a:latin typeface="Segoe UI"/>
+              </a:rPr>
+              <a:t>Always 5</a:t>
+            </a:r>
+          </a:p>
+        </p:txBody>
+      </p:sp>
+      <p:sp>
+        <p:nvSpPr>
+          <p:cNvPr id="11" name="Rounded Rectangle 10"/>
           <p:cNvSpPr/>
           <p:nvPr/>
         </p:nvSpPr>
         <p:spPr>
           <a:xfrm>
-            <a:off x="640080" y="3310128"/>
-            <a:ext cx="10908792" cy="1234440"/>
+            <a:off x="640080" y="2670048"/>
+            <a:ext cx="10908792" cy="731520"/>
           </a:xfrm>
           <a:prstGeom prst="roundRect">
             <a:avLst/>
@@ -7135,20 +7108,64 @@
       </p:sp>
       <p:sp>
         <p:nvSpPr>
-          <p:cNvPr id="11" name="Rectangle 10"/>
+          <p:cNvPr id="12" name="TextBox 11"/>
+          <p:cNvSpPr txBox="1"/>
+          <p:nvPr/>
+        </p:nvSpPr>
+        <p:spPr>
+          <a:xfrm>
+            <a:off x="1005840" y="2670048"/>
+            <a:ext cx="8074151" cy="731520"/>
+          </a:xfrm>
+          <a:prstGeom prst="rect">
+            <a:avLst/>
+          </a:prstGeom>
+          <a:noFill/>
+        </p:spPr>
+        <p:txBody>
+          <a:bodyPr wrap="square" anchor="ctr" lIns="0" rIns="0" tIns="0" bIns="0">
+            <a:spAutoFit/>
+          </a:bodyPr>
+          <a:lstStyle/>
+          <a:p>
+            <a:pPr algn="l"/>
+            <a:r>
+              <a:rPr sz="1650" b="1">
+                <a:solidFill>
+                  <a:srgbClr val="1A2332"/>
+                </a:solidFill>
+                <a:latin typeface="Segoe UI"/>
+              </a:rPr>
+              <a:t>DM and above    </a:t>
+            </a:r>
+            <a:r>
+              <a:rPr sz="1300" b="0">
+                <a:solidFill>
+                  <a:srgbClr val="5E665E"/>
+                </a:solidFill>
+                <a:latin typeface="Segoe UI"/>
+              </a:rPr>
+              <a:t>District managers, regionals, VPs</a:t>
+            </a:r>
+          </a:p>
+        </p:txBody>
+      </p:sp>
+      <p:sp>
+        <p:nvSpPr>
+          <p:cNvPr id="13" name="Rounded Rectangle 12"/>
           <p:cNvSpPr/>
           <p:nvPr/>
         </p:nvSpPr>
         <p:spPr>
           <a:xfrm>
-            <a:off x="640080" y="3310128"/>
-            <a:ext cx="164592" cy="1234440"/>
-          </a:xfrm>
-          <a:prstGeom prst="rect">
+            <a:off x="9281159" y="2788920"/>
+            <a:ext cx="2103120" cy="493776"/>
+          </a:xfrm>
+          <a:prstGeom prst="roundRect">
             <a:avLst/>
           </a:prstGeom>
           <a:solidFill>
-            <a:srgbClr val="29A9E1"/>
+            <a:srgbClr val="5EBA28"/>
           </a:solidFill>
           <a:ln>
             <a:noFill/>
@@ -7179,14 +7196,14 @@
       </p:sp>
       <p:sp>
         <p:nvSpPr>
-          <p:cNvPr id="12" name="TextBox 11"/>
+          <p:cNvPr id="14" name="TextBox 13"/>
           <p:cNvSpPr txBox="1"/>
           <p:nvPr/>
         </p:nvSpPr>
         <p:spPr>
           <a:xfrm>
-            <a:off x="1143000" y="3310128"/>
-            <a:ext cx="10085832" cy="1234440"/>
+            <a:off x="9281159" y="2788920"/>
+            <a:ext cx="2103120" cy="493776"/>
           </a:xfrm>
           <a:prstGeom prst="rect">
             <a:avLst/>
@@ -7199,49 +7216,29 @@
           </a:bodyPr>
           <a:lstStyle/>
           <a:p>
-            <a:pPr algn="l">
-              <a:spcAft>
-                <a:spcPts val="700"/>
-              </a:spcAft>
-            </a:pPr>
-            <a:r>
-              <a:rPr sz="1800" b="1">
-                <a:solidFill>
-                  <a:srgbClr val="1A2332"/>
-                </a:solidFill>
-                <a:latin typeface="Segoe UI"/>
-              </a:rPr>
-              <a:t>How tenure reads</a:t>
-            </a:r>
-          </a:p>
-          <a:p>
-            <a:pPr algn="l">
-              <a:spcAft>
-                <a:spcPts val="700"/>
-              </a:spcAft>
-            </a:pPr>
-            <a:r>
-              <a:rPr sz="1450" b="0">
-                <a:solidFill>
-                  <a:srgbClr val="5E665E"/>
-                </a:solidFill>
-                <a:latin typeface="Segoe UI"/>
-              </a:rPr>
-              <a:t>Counted from time on leads. That tracks hire date for Traditional, but not for Direct, whose path runs prime to graduate to director.</a:t>
-            </a:r>
-          </a:p>
-        </p:txBody>
-      </p:sp>
-      <p:sp>
-        <p:nvSpPr>
-          <p:cNvPr id="13" name="Rounded Rectangle 12"/>
+            <a:pPr algn="ctr"/>
+            <a:r>
+              <a:rPr sz="1500" b="1">
+                <a:solidFill>
+                  <a:srgbClr val="FFFFFF"/>
+                </a:solidFill>
+                <a:latin typeface="Segoe UI"/>
+              </a:rPr>
+              <a:t>At least 4</a:t>
+            </a:r>
+          </a:p>
+        </p:txBody>
+      </p:sp>
+      <p:sp>
+        <p:nvSpPr>
+          <p:cNvPr id="15" name="Rounded Rectangle 14"/>
           <p:cNvSpPr/>
           <p:nvPr/>
         </p:nvSpPr>
         <p:spPr>
           <a:xfrm>
-            <a:off x="640080" y="4745736"/>
-            <a:ext cx="10908792" cy="1234440"/>
+            <a:off x="640080" y="3529584"/>
+            <a:ext cx="10908792" cy="731520"/>
           </a:xfrm>
           <a:prstGeom prst="roundRect">
             <a:avLst/>
@@ -7280,16 +7277,60 @@
       </p:sp>
       <p:sp>
         <p:nvSpPr>
-          <p:cNvPr id="14" name="Rectangle 13"/>
+          <p:cNvPr id="16" name="TextBox 15"/>
+          <p:cNvSpPr txBox="1"/>
+          <p:nvPr/>
+        </p:nvSpPr>
+        <p:spPr>
+          <a:xfrm>
+            <a:off x="1005840" y="3529584"/>
+            <a:ext cx="8074151" cy="731520"/>
+          </a:xfrm>
+          <a:prstGeom prst="rect">
+            <a:avLst/>
+          </a:prstGeom>
+          <a:noFill/>
+        </p:spPr>
+        <p:txBody>
+          <a:bodyPr wrap="square" anchor="ctr" lIns="0" rIns="0" tIns="0" bIns="0">
+            <a:spAutoFit/>
+          </a:bodyPr>
+          <a:lstStyle/>
+          <a:p>
+            <a:pPr algn="l"/>
+            <a:r>
+              <a:rPr sz="1650" b="1">
+                <a:solidFill>
+                  <a:srgbClr val="1A2332"/>
+                </a:solidFill>
+                <a:latin typeface="Segoe UI"/>
+              </a:rPr>
+              <a:t>ADM / Training Manager    </a:t>
+            </a:r>
+            <a:r>
+              <a:rPr sz="1300" b="0">
+                <a:solidFill>
+                  <a:srgbClr val="5E665E"/>
+                </a:solidFill>
+                <a:latin typeface="Segoe UI"/>
+              </a:rPr>
+              <a:t>Assistant district and training managers</a:t>
+            </a:r>
+          </a:p>
+        </p:txBody>
+      </p:sp>
+      <p:sp>
+        <p:nvSpPr>
+          <p:cNvPr id="17" name="Rounded Rectangle 16"/>
           <p:cNvSpPr/>
           <p:nvPr/>
         </p:nvSpPr>
         <p:spPr>
           <a:xfrm>
-            <a:off x="640080" y="4745736"/>
-            <a:ext cx="164592" cy="1234440"/>
-          </a:xfrm>
-          <a:prstGeom prst="rect">
+            <a:off x="9281159" y="3648456"/>
+            <a:ext cx="2103120" cy="493776"/>
+          </a:xfrm>
+          <a:prstGeom prst="roundRect">
             <a:avLst/>
           </a:prstGeom>
           <a:solidFill>
@@ -7324,14 +7365,14 @@
       </p:sp>
       <p:sp>
         <p:nvSpPr>
-          <p:cNvPr id="15" name="TextBox 14"/>
+          <p:cNvPr id="18" name="TextBox 17"/>
           <p:cNvSpPr txBox="1"/>
           <p:nvPr/>
         </p:nvSpPr>
         <p:spPr>
           <a:xfrm>
-            <a:off x="1143000" y="4745736"/>
-            <a:ext cx="10085832" cy="1234440"/>
+            <a:off x="9281159" y="3648456"/>
+            <a:ext cx="2103120" cy="493776"/>
           </a:xfrm>
           <a:prstGeom prst="rect">
             <a:avLst/>
@@ -7344,35 +7385,388 @@
           </a:bodyPr>
           <a:lstStyle/>
           <a:p>
-            <a:pPr algn="l">
-              <a:spcAft>
-                <a:spcPts val="700"/>
-              </a:spcAft>
-            </a:pPr>
-            <a:r>
-              <a:rPr sz="1800" b="1">
+            <a:pPr algn="ctr"/>
+            <a:r>
+              <a:rPr sz="1500" b="1">
+                <a:solidFill>
+                  <a:srgbClr val="FFFFFF"/>
+                </a:solidFill>
+                <a:latin typeface="Segoe UI"/>
+              </a:rPr>
+              <a:t>At least 3</a:t>
+            </a:r>
+          </a:p>
+        </p:txBody>
+      </p:sp>
+      <p:sp>
+        <p:nvSpPr>
+          <p:cNvPr id="19" name="Rounded Rectangle 18"/>
+          <p:cNvSpPr/>
+          <p:nvPr/>
+        </p:nvSpPr>
+        <p:spPr>
+          <a:xfrm>
+            <a:off x="640080" y="4389120"/>
+            <a:ext cx="10908792" cy="731520"/>
+          </a:xfrm>
+          <a:prstGeom prst="roundRect">
+            <a:avLst/>
+          </a:prstGeom>
+          <a:solidFill>
+            <a:srgbClr val="EFF1EC"/>
+          </a:solidFill>
+          <a:ln w="9525">
+            <a:solidFill>
+              <a:srgbClr val="D8DDD4"/>
+            </a:solidFill>
+          </a:ln>
+          <a:effectLst/>
+        </p:spPr>
+        <p:style>
+          <a:lnRef idx="1">
+            <a:schemeClr val="accent1"/>
+          </a:lnRef>
+          <a:fillRef idx="3">
+            <a:schemeClr val="accent1"/>
+          </a:fillRef>
+          <a:effectRef idx="2">
+            <a:schemeClr val="accent1"/>
+          </a:effectRef>
+          <a:fontRef idx="minor">
+            <a:schemeClr val="lt1"/>
+          </a:fontRef>
+        </p:style>
+        <p:txBody>
+          <a:bodyPr rtlCol="0" anchor="ctr"/>
+          <a:lstStyle/>
+          <a:p>
+            <a:pPr algn="ctr"/>
+          </a:p>
+        </p:txBody>
+      </p:sp>
+      <p:sp>
+        <p:nvSpPr>
+          <p:cNvPr id="20" name="TextBox 19"/>
+          <p:cNvSpPr txBox="1"/>
+          <p:nvPr/>
+        </p:nvSpPr>
+        <p:spPr>
+          <a:xfrm>
+            <a:off x="1005840" y="4389120"/>
+            <a:ext cx="8074151" cy="731520"/>
+          </a:xfrm>
+          <a:prstGeom prst="rect">
+            <a:avLst/>
+          </a:prstGeom>
+          <a:noFill/>
+        </p:spPr>
+        <p:txBody>
+          <a:bodyPr wrap="square" anchor="ctr" lIns="0" rIns="0" tIns="0" bIns="0">
+            <a:spAutoFit/>
+          </a:bodyPr>
+          <a:lstStyle/>
+          <a:p>
+            <a:pPr algn="l"/>
+            <a:r>
+              <a:rPr sz="1650" b="1">
                 <a:solidFill>
                   <a:srgbClr val="1A2332"/>
                 </a:solidFill>
                 <a:latin typeface="Segoe UI"/>
               </a:rPr>
-              <a:t>Your pool</a:t>
-            </a:r>
-          </a:p>
-          <a:p>
-            <a:pPr algn="l">
-              <a:spcAft>
-                <a:spcPts val="700"/>
-              </a:spcAft>
-            </a:pPr>
-            <a:r>
-              <a:rPr sz="1450" b="0">
+              <a:t>New hire    </a:t>
+            </a:r>
+            <a:r>
+              <a:rPr sz="1300" b="0">
                 <a:solidFill>
                   <a:srgbClr val="5E665E"/>
                 </a:solidFill>
                 <a:latin typeface="Segoe UI"/>
               </a:rPr>
-              <a:t>Ranked against your own channel and region. Direct vs Direct, Traditional vs Traditional, never across.</a:t>
+              <a:t>First 40 appointments or 8 months</a:t>
+            </a:r>
+          </a:p>
+        </p:txBody>
+      </p:sp>
+      <p:sp>
+        <p:nvSpPr>
+          <p:cNvPr id="21" name="Rounded Rectangle 20"/>
+          <p:cNvSpPr/>
+          <p:nvPr/>
+        </p:nvSpPr>
+        <p:spPr>
+          <a:xfrm>
+            <a:off x="9281159" y="4507992"/>
+            <a:ext cx="2103120" cy="493776"/>
+          </a:xfrm>
+          <a:prstGeom prst="roundRect">
+            <a:avLst/>
+          </a:prstGeom>
+          <a:solidFill>
+            <a:srgbClr val="5EBA28"/>
+          </a:solidFill>
+          <a:ln>
+            <a:noFill/>
+          </a:ln>
+          <a:effectLst/>
+        </p:spPr>
+        <p:style>
+          <a:lnRef idx="1">
+            <a:schemeClr val="accent1"/>
+          </a:lnRef>
+          <a:fillRef idx="3">
+            <a:schemeClr val="accent1"/>
+          </a:fillRef>
+          <a:effectRef idx="2">
+            <a:schemeClr val="accent1"/>
+          </a:effectRef>
+          <a:fontRef idx="minor">
+            <a:schemeClr val="lt1"/>
+          </a:fontRef>
+        </p:style>
+        <p:txBody>
+          <a:bodyPr rtlCol="0" anchor="ctr"/>
+          <a:lstStyle/>
+          <a:p>
+            <a:pPr algn="ctr"/>
+          </a:p>
+        </p:txBody>
+      </p:sp>
+      <p:sp>
+        <p:nvSpPr>
+          <p:cNvPr id="22" name="TextBox 21"/>
+          <p:cNvSpPr txBox="1"/>
+          <p:nvPr/>
+        </p:nvSpPr>
+        <p:spPr>
+          <a:xfrm>
+            <a:off x="9281159" y="4507992"/>
+            <a:ext cx="2103120" cy="493776"/>
+          </a:xfrm>
+          <a:prstGeom prst="rect">
+            <a:avLst/>
+          </a:prstGeom>
+          <a:noFill/>
+        </p:spPr>
+        <p:txBody>
+          <a:bodyPr wrap="square" anchor="ctr" lIns="0" rIns="0" tIns="0" bIns="0">
+            <a:spAutoFit/>
+          </a:bodyPr>
+          <a:lstStyle/>
+          <a:p>
+            <a:pPr algn="ctr"/>
+            <a:r>
+              <a:rPr sz="1500" b="1">
+                <a:solidFill>
+                  <a:srgbClr val="FFFFFF"/>
+                </a:solidFill>
+                <a:latin typeface="Segoe UI"/>
+              </a:rPr>
+              <a:t>At least 3</a:t>
+            </a:r>
+          </a:p>
+        </p:txBody>
+      </p:sp>
+      <p:sp>
+        <p:nvSpPr>
+          <p:cNvPr id="23" name="Rounded Rectangle 22"/>
+          <p:cNvSpPr/>
+          <p:nvPr/>
+        </p:nvSpPr>
+        <p:spPr>
+          <a:xfrm>
+            <a:off x="640080" y="5248656"/>
+            <a:ext cx="10908792" cy="731520"/>
+          </a:xfrm>
+          <a:prstGeom prst="roundRect">
+            <a:avLst/>
+          </a:prstGeom>
+          <a:solidFill>
+            <a:srgbClr val="EFF1EC"/>
+          </a:solidFill>
+          <a:ln w="9525">
+            <a:solidFill>
+              <a:srgbClr val="D8DDD4"/>
+            </a:solidFill>
+          </a:ln>
+          <a:effectLst/>
+        </p:spPr>
+        <p:style>
+          <a:lnRef idx="1">
+            <a:schemeClr val="accent1"/>
+          </a:lnRef>
+          <a:fillRef idx="3">
+            <a:schemeClr val="accent1"/>
+          </a:fillRef>
+          <a:effectRef idx="2">
+            <a:schemeClr val="accent1"/>
+          </a:effectRef>
+          <a:fontRef idx="minor">
+            <a:schemeClr val="lt1"/>
+          </a:fontRef>
+        </p:style>
+        <p:txBody>
+          <a:bodyPr rtlCol="0" anchor="ctr"/>
+          <a:lstStyle/>
+          <a:p>
+            <a:pPr algn="ctr"/>
+          </a:p>
+        </p:txBody>
+      </p:sp>
+      <p:sp>
+        <p:nvSpPr>
+          <p:cNvPr id="24" name="TextBox 23"/>
+          <p:cNvSpPr txBox="1"/>
+          <p:nvPr/>
+        </p:nvSpPr>
+        <p:spPr>
+          <a:xfrm>
+            <a:off x="1005840" y="5248656"/>
+            <a:ext cx="8074151" cy="731520"/>
+          </a:xfrm>
+          <a:prstGeom prst="rect">
+            <a:avLst/>
+          </a:prstGeom>
+          <a:noFill/>
+        </p:spPr>
+        <p:txBody>
+          <a:bodyPr wrap="square" anchor="ctr" lIns="0" rIns="0" tIns="0" bIns="0">
+            <a:spAutoFit/>
+          </a:bodyPr>
+          <a:lstStyle/>
+          <a:p>
+            <a:pPr algn="l"/>
+            <a:r>
+              <a:rPr sz="1650" b="1">
+                <a:solidFill>
+                  <a:srgbClr val="1A2332"/>
+                </a:solidFill>
+                <a:latin typeface="Segoe UI"/>
+              </a:rPr>
+              <a:t>Low volume    </a:t>
+            </a:r>
+            <a:r>
+              <a:rPr sz="1300" b="0">
+                <a:solidFill>
+                  <a:srgbClr val="5E665E"/>
+                </a:solidFill>
+                <a:latin typeface="Segoe UI"/>
+              </a:rPr>
+              <a:t>Too few at-bats (under 15 / 20 / 30 by channel)</a:t>
+            </a:r>
+          </a:p>
+        </p:txBody>
+      </p:sp>
+      <p:sp>
+        <p:nvSpPr>
+          <p:cNvPr id="25" name="Rounded Rectangle 24"/>
+          <p:cNvSpPr/>
+          <p:nvPr/>
+        </p:nvSpPr>
+        <p:spPr>
+          <a:xfrm>
+            <a:off x="9281159" y="5367528"/>
+            <a:ext cx="2103120" cy="493776"/>
+          </a:xfrm>
+          <a:prstGeom prst="roundRect">
+            <a:avLst/>
+          </a:prstGeom>
+          <a:solidFill>
+            <a:srgbClr val="5E665E"/>
+          </a:solidFill>
+          <a:ln>
+            <a:noFill/>
+          </a:ln>
+          <a:effectLst/>
+        </p:spPr>
+        <p:style>
+          <a:lnRef idx="1">
+            <a:schemeClr val="accent1"/>
+          </a:lnRef>
+          <a:fillRef idx="3">
+            <a:schemeClr val="accent1"/>
+          </a:fillRef>
+          <a:effectRef idx="2">
+            <a:schemeClr val="accent1"/>
+          </a:effectRef>
+          <a:fontRef idx="minor">
+            <a:schemeClr val="lt1"/>
+          </a:fontRef>
+        </p:style>
+        <p:txBody>
+          <a:bodyPr rtlCol="0" anchor="ctr"/>
+          <a:lstStyle/>
+          <a:p>
+            <a:pPr algn="ctr"/>
+          </a:p>
+        </p:txBody>
+      </p:sp>
+      <p:sp>
+        <p:nvSpPr>
+          <p:cNvPr id="26" name="TextBox 25"/>
+          <p:cNvSpPr txBox="1"/>
+          <p:nvPr/>
+        </p:nvSpPr>
+        <p:spPr>
+          <a:xfrm>
+            <a:off x="9281159" y="5367528"/>
+            <a:ext cx="2103120" cy="493776"/>
+          </a:xfrm>
+          <a:prstGeom prst="rect">
+            <a:avLst/>
+          </a:prstGeom>
+          <a:noFill/>
+        </p:spPr>
+        <p:txBody>
+          <a:bodyPr wrap="square" anchor="ctr" lIns="0" rIns="0" tIns="0" bIns="0">
+            <a:spAutoFit/>
+          </a:bodyPr>
+          <a:lstStyle/>
+          <a:p>
+            <a:pPr algn="ctr"/>
+            <a:r>
+              <a:rPr sz="1500" b="1">
+                <a:solidFill>
+                  <a:srgbClr val="FFFFFF"/>
+                </a:solidFill>
+                <a:latin typeface="Segoe UI"/>
+              </a:rPr>
+              <a:t>Caps at 4</a:t>
+            </a:r>
+          </a:p>
+        </p:txBody>
+      </p:sp>
+      <p:sp>
+        <p:nvSpPr>
+          <p:cNvPr id="27" name="TextBox 26"/>
+          <p:cNvSpPr txBox="1"/>
+          <p:nvPr/>
+        </p:nvSpPr>
+        <p:spPr>
+          <a:xfrm>
+            <a:off x="640080" y="6144768"/>
+            <a:ext cx="10908792" cy="365760"/>
+          </a:xfrm>
+          <a:prstGeom prst="rect">
+            <a:avLst/>
+          </a:prstGeom>
+          <a:noFill/>
+        </p:spPr>
+        <p:txBody>
+          <a:bodyPr wrap="square" anchor="t" lIns="0" rIns="0" tIns="0" bIns="0">
+            <a:spAutoFit/>
+          </a:bodyPr>
+          <a:lstStyle/>
+          <a:p>
+            <a:pPr algn="l"/>
+            <a:r>
+              <a:rPr sz="1250" b="0">
+                <a:solidFill>
+                  <a:srgbClr val="5E665E"/>
+                </a:solidFill>
+                <a:latin typeface="Segoe UI"/>
+              </a:rPr>
+              <a:t>A floor is a minimum, not a ceiling. Earn higher and you keep it. Only Hall of Fame is automatic.</a:t>
             </a:r>
           </a:p>
         </p:txBody>
@@ -7557,7 +7951,7 @@
                 </a:solidFill>
                 <a:latin typeface="Segoe UI"/>
               </a:rPr>
-              <a:t>Guardrails: floors and a cap</a:t>
+              <a:t>In practice: one rep, one week</a:t>
             </a:r>
           </a:p>
         </p:txBody>
@@ -7592,7 +7986,7 @@
                 </a:solidFill>
                 <a:latin typeface="Segoe UI"/>
               </a:rPr>
-              <a:t>Most reps earn their rank outright. A few cases get a floor or a cap.</a:t>
+              <a:t>Real numbers from the last run, name withheld.</a:t>
             </a:r>
           </a:p>
         </p:txBody>
@@ -7605,8 +7999,8 @@
         </p:nvSpPr>
         <p:spPr>
           <a:xfrm>
-            <a:off x="640080" y="1810512"/>
-            <a:ext cx="10908792" cy="731520"/>
+            <a:off x="640080" y="1874519"/>
+            <a:ext cx="1998878" cy="1691640"/>
           </a:xfrm>
           <a:prstGeom prst="roundRect">
             <a:avLst/>
@@ -7651,8 +8045,8 @@
         </p:nvSpPr>
         <p:spPr>
           <a:xfrm>
-            <a:off x="1005840" y="1810512"/>
-            <a:ext cx="8074151" cy="731520"/>
+            <a:off x="640080" y="2075688"/>
+            <a:ext cx="1998878" cy="365760"/>
           </a:xfrm>
           <a:prstGeom prst="rect">
             <a:avLst/>
@@ -7665,24 +8059,15 @@
           </a:bodyPr>
           <a:lstStyle/>
           <a:p>
-            <a:pPr algn="l"/>
-            <a:r>
-              <a:rPr sz="1650" b="1">
-                <a:solidFill>
-                  <a:srgbClr val="1A2332"/>
-                </a:solidFill>
-                <a:latin typeface="Segoe UI"/>
-              </a:rPr>
-              <a:t>Hall of Fame    </a:t>
-            </a:r>
-            <a:r>
-              <a:rPr sz="1300" b="0">
+            <a:pPr algn="ctr"/>
+            <a:r>
+              <a:rPr sz="1350" b="1">
                 <a:solidFill>
                   <a:srgbClr val="5E665E"/>
                 </a:solidFill>
                 <a:latin typeface="Segoe UI"/>
               </a:rPr>
-              <a:t>1,000+ career installs</a:t>
+              <a:t>Effective</a:t>
             </a:r>
           </a:p>
         </p:txBody>
@@ -7695,14 +8080,14 @@
         </p:nvSpPr>
         <p:spPr>
           <a:xfrm>
-            <a:off x="9281159" y="1929384"/>
-            <a:ext cx="2103120" cy="493776"/>
+            <a:off x="1205179" y="2441448"/>
+            <a:ext cx="868680" cy="64008"/>
           </a:xfrm>
           <a:prstGeom prst="roundRect">
             <a:avLst/>
           </a:prstGeom>
           <a:solidFill>
-            <a:srgbClr val="4F9D28"/>
+            <a:srgbClr val="5EBA28"/>
           </a:solidFill>
           <a:ln>
             <a:noFill/>
@@ -7739,8 +8124,8 @@
         </p:nvSpPr>
         <p:spPr>
           <a:xfrm>
-            <a:off x="9281159" y="1929384"/>
-            <a:ext cx="2103120" cy="493776"/>
+            <a:off x="640080" y="2587752"/>
+            <a:ext cx="1998878" cy="548640"/>
           </a:xfrm>
           <a:prstGeom prst="rect">
             <a:avLst/>
@@ -7755,27 +8140,62 @@
           <a:p>
             <a:pPr algn="ctr"/>
             <a:r>
-              <a:rPr sz="1500" b="1">
-                <a:solidFill>
-                  <a:srgbClr val="FFFFFF"/>
-                </a:solidFill>
-                <a:latin typeface="Segoe UI"/>
-              </a:rPr>
-              <a:t>Always 5</a:t>
-            </a:r>
-          </a:p>
-        </p:txBody>
-      </p:sp>
-      <p:sp>
-        <p:nvSpPr>
-          <p:cNvPr id="11" name="Rounded Rectangle 10"/>
+              <a:rPr sz="3000" b="1">
+                <a:solidFill>
+                  <a:srgbClr val="1A2332"/>
+                </a:solidFill>
+                <a:latin typeface="Segoe UI"/>
+              </a:rPr>
+              <a:t>26%</a:t>
+            </a:r>
+          </a:p>
+        </p:txBody>
+      </p:sp>
+      <p:sp>
+        <p:nvSpPr>
+          <p:cNvPr id="11" name="TextBox 10"/>
+          <p:cNvSpPr txBox="1"/>
+          <p:nvPr/>
+        </p:nvSpPr>
+        <p:spPr>
+          <a:xfrm>
+            <a:off x="640080" y="3172968"/>
+            <a:ext cx="1998878" cy="320040"/>
+          </a:xfrm>
+          <a:prstGeom prst="rect">
+            <a:avLst/>
+          </a:prstGeom>
+          <a:noFill/>
+        </p:spPr>
+        <p:txBody>
+          <a:bodyPr wrap="square" anchor="ctr" lIns="0" rIns="0" tIns="0" bIns="0">
+            <a:spAutoFit/>
+          </a:bodyPr>
+          <a:lstStyle/>
+          <a:p>
+            <a:pPr algn="ctr"/>
+            <a:r>
+              <a:rPr sz="1200" b="0">
+                <a:solidFill>
+                  <a:srgbClr val="5E665E"/>
+                </a:solidFill>
+                <a:latin typeface="Segoe UI"/>
+              </a:rPr>
+              <a:t>target 30%</a:t>
+            </a:r>
+          </a:p>
+        </p:txBody>
+      </p:sp>
+      <p:sp>
+        <p:nvSpPr>
+          <p:cNvPr id="12" name="Rounded Rectangle 11"/>
           <p:cNvSpPr/>
           <p:nvPr/>
         </p:nvSpPr>
         <p:spPr>
           <a:xfrm>
-            <a:off x="640080" y="2670048"/>
-            <a:ext cx="10908792" cy="731520"/>
+            <a:off x="2867558" y="1874519"/>
+            <a:ext cx="1998878" cy="1691640"/>
           </a:xfrm>
           <a:prstGeom prst="roundRect">
             <a:avLst/>
@@ -7814,14 +8234,14 @@
       </p:sp>
       <p:sp>
         <p:nvSpPr>
-          <p:cNvPr id="12" name="TextBox 11"/>
+          <p:cNvPr id="13" name="TextBox 12"/>
           <p:cNvSpPr txBox="1"/>
           <p:nvPr/>
         </p:nvSpPr>
         <p:spPr>
           <a:xfrm>
-            <a:off x="1005840" y="2670048"/>
-            <a:ext cx="8074151" cy="731520"/>
+            <a:off x="2867558" y="2075688"/>
+            <a:ext cx="1998878" cy="365760"/>
           </a:xfrm>
           <a:prstGeom prst="rect">
             <a:avLst/>
@@ -7834,38 +8254,29 @@
           </a:bodyPr>
           <a:lstStyle/>
           <a:p>
-            <a:pPr algn="l"/>
-            <a:r>
-              <a:rPr sz="1650" b="1">
-                <a:solidFill>
-                  <a:srgbClr val="1A2332"/>
-                </a:solidFill>
-                <a:latin typeface="Segoe UI"/>
-              </a:rPr>
-              <a:t>DM and above    </a:t>
-            </a:r>
-            <a:r>
-              <a:rPr sz="1300" b="0">
+            <a:pPr algn="ctr"/>
+            <a:r>
+              <a:rPr sz="1350" b="1">
                 <a:solidFill>
                   <a:srgbClr val="5E665E"/>
                 </a:solidFill>
                 <a:latin typeface="Segoe UI"/>
               </a:rPr>
-              <a:t>District managers, regionals, VPs</a:t>
-            </a:r>
-          </a:p>
-        </p:txBody>
-      </p:sp>
-      <p:sp>
-        <p:nvSpPr>
-          <p:cNvPr id="13" name="Rounded Rectangle 12"/>
+              <a:t>Pull-through</a:t>
+            </a:r>
+          </a:p>
+        </p:txBody>
+      </p:sp>
+      <p:sp>
+        <p:nvSpPr>
+          <p:cNvPr id="14" name="Rounded Rectangle 13"/>
           <p:cNvSpPr/>
           <p:nvPr/>
         </p:nvSpPr>
         <p:spPr>
           <a:xfrm>
-            <a:off x="9281159" y="2788920"/>
-            <a:ext cx="2103120" cy="493776"/>
+            <a:off x="3432657" y="2441448"/>
+            <a:ext cx="868680" cy="64008"/>
           </a:xfrm>
           <a:prstGeom prst="roundRect">
             <a:avLst/>
@@ -7902,14 +8313,14 @@
       </p:sp>
       <p:sp>
         <p:nvSpPr>
-          <p:cNvPr id="14" name="TextBox 13"/>
+          <p:cNvPr id="15" name="TextBox 14"/>
           <p:cNvSpPr txBox="1"/>
           <p:nvPr/>
         </p:nvSpPr>
         <p:spPr>
           <a:xfrm>
-            <a:off x="9281159" y="2788920"/>
-            <a:ext cx="2103120" cy="493776"/>
+            <a:off x="2867558" y="2587752"/>
+            <a:ext cx="1998878" cy="548640"/>
           </a:xfrm>
           <a:prstGeom prst="rect">
             <a:avLst/>
@@ -7924,27 +8335,62 @@
           <a:p>
             <a:pPr algn="ctr"/>
             <a:r>
-              <a:rPr sz="1500" b="1">
-                <a:solidFill>
-                  <a:srgbClr val="FFFFFF"/>
-                </a:solidFill>
-                <a:latin typeface="Segoe UI"/>
-              </a:rPr>
-              <a:t>At least 4</a:t>
-            </a:r>
-          </a:p>
-        </p:txBody>
-      </p:sp>
-      <p:sp>
-        <p:nvSpPr>
-          <p:cNvPr id="15" name="Rounded Rectangle 14"/>
+              <a:rPr sz="3000" b="1">
+                <a:solidFill>
+                  <a:srgbClr val="1A2332"/>
+                </a:solidFill>
+                <a:latin typeface="Segoe UI"/>
+              </a:rPr>
+              <a:t>78%</a:t>
+            </a:r>
+          </a:p>
+        </p:txBody>
+      </p:sp>
+      <p:sp>
+        <p:nvSpPr>
+          <p:cNvPr id="16" name="TextBox 15"/>
+          <p:cNvSpPr txBox="1"/>
+          <p:nvPr/>
+        </p:nvSpPr>
+        <p:spPr>
+          <a:xfrm>
+            <a:off x="2867558" y="3172968"/>
+            <a:ext cx="1998878" cy="320040"/>
+          </a:xfrm>
+          <a:prstGeom prst="rect">
+            <a:avLst/>
+          </a:prstGeom>
+          <a:noFill/>
+        </p:spPr>
+        <p:txBody>
+          <a:bodyPr wrap="square" anchor="ctr" lIns="0" rIns="0" tIns="0" bIns="0">
+            <a:spAutoFit/>
+          </a:bodyPr>
+          <a:lstStyle/>
+          <a:p>
+            <a:pPr algn="ctr"/>
+            <a:r>
+              <a:rPr sz="1200" b="0">
+                <a:solidFill>
+                  <a:srgbClr val="5E665E"/>
+                </a:solidFill>
+                <a:latin typeface="Segoe UI"/>
+              </a:rPr>
+              <a:t>target 80%</a:t>
+            </a:r>
+          </a:p>
+        </p:txBody>
+      </p:sp>
+      <p:sp>
+        <p:nvSpPr>
+          <p:cNvPr id="17" name="Rounded Rectangle 16"/>
           <p:cNvSpPr/>
           <p:nvPr/>
         </p:nvSpPr>
         <p:spPr>
           <a:xfrm>
-            <a:off x="640080" y="3529584"/>
-            <a:ext cx="10908792" cy="731520"/>
+            <a:off x="5095036" y="1874519"/>
+            <a:ext cx="1998878" cy="1691640"/>
           </a:xfrm>
           <a:prstGeom prst="roundRect">
             <a:avLst/>
@@ -7983,14 +8429,14 @@
       </p:sp>
       <p:sp>
         <p:nvSpPr>
-          <p:cNvPr id="16" name="TextBox 15"/>
+          <p:cNvPr id="18" name="TextBox 17"/>
           <p:cNvSpPr txBox="1"/>
           <p:nvPr/>
         </p:nvSpPr>
         <p:spPr>
           <a:xfrm>
-            <a:off x="1005840" y="3529584"/>
-            <a:ext cx="8074151" cy="731520"/>
+            <a:off x="5095036" y="2075688"/>
+            <a:ext cx="1998878" cy="365760"/>
           </a:xfrm>
           <a:prstGeom prst="rect">
             <a:avLst/>
@@ -8003,44 +8449,35 @@
           </a:bodyPr>
           <a:lstStyle/>
           <a:p>
-            <a:pPr algn="l"/>
-            <a:r>
-              <a:rPr sz="1650" b="1">
-                <a:solidFill>
-                  <a:srgbClr val="1A2332"/>
-                </a:solidFill>
-                <a:latin typeface="Segoe UI"/>
-              </a:rPr>
-              <a:t>ADM / Training Manager    </a:t>
-            </a:r>
-            <a:r>
-              <a:rPr sz="1300" b="0">
+            <a:pPr algn="ctr"/>
+            <a:r>
+              <a:rPr sz="1350" b="1">
                 <a:solidFill>
                   <a:srgbClr val="5E665E"/>
                 </a:solidFill>
                 <a:latin typeface="Segoe UI"/>
               </a:rPr>
-              <a:t>Assistant district and training managers</a:t>
-            </a:r>
-          </a:p>
-        </p:txBody>
-      </p:sp>
-      <p:sp>
-        <p:nvSpPr>
-          <p:cNvPr id="17" name="Rounded Rectangle 16"/>
+              <a:t>Attachment</a:t>
+            </a:r>
+          </a:p>
+        </p:txBody>
+      </p:sp>
+      <p:sp>
+        <p:nvSpPr>
+          <p:cNvPr id="19" name="Rounded Rectangle 18"/>
           <p:cNvSpPr/>
           <p:nvPr/>
         </p:nvSpPr>
         <p:spPr>
           <a:xfrm>
-            <a:off x="9281159" y="3648456"/>
-            <a:ext cx="2103120" cy="493776"/>
+            <a:off x="5660136" y="2441448"/>
+            <a:ext cx="868680" cy="64008"/>
           </a:xfrm>
           <a:prstGeom prst="roundRect">
             <a:avLst/>
           </a:prstGeom>
           <a:solidFill>
-            <a:srgbClr val="5EBA28"/>
+            <a:srgbClr val="29A9E1"/>
           </a:solidFill>
           <a:ln>
             <a:noFill/>
@@ -8071,14 +8508,14 @@
       </p:sp>
       <p:sp>
         <p:nvSpPr>
-          <p:cNvPr id="18" name="TextBox 17"/>
+          <p:cNvPr id="20" name="TextBox 19"/>
           <p:cNvSpPr txBox="1"/>
           <p:nvPr/>
         </p:nvSpPr>
         <p:spPr>
           <a:xfrm>
-            <a:off x="9281159" y="3648456"/>
-            <a:ext cx="2103120" cy="493776"/>
+            <a:off x="5095036" y="2587752"/>
+            <a:ext cx="1998878" cy="548640"/>
           </a:xfrm>
           <a:prstGeom prst="rect">
             <a:avLst/>
@@ -8093,27 +8530,62 @@
           <a:p>
             <a:pPr algn="ctr"/>
             <a:r>
-              <a:rPr sz="1500" b="1">
-                <a:solidFill>
-                  <a:srgbClr val="FFFFFF"/>
-                </a:solidFill>
-                <a:latin typeface="Segoe UI"/>
-              </a:rPr>
-              <a:t>At least 3</a:t>
-            </a:r>
-          </a:p>
-        </p:txBody>
-      </p:sp>
-      <p:sp>
-        <p:nvSpPr>
-          <p:cNvPr id="19" name="Rounded Rectangle 18"/>
+              <a:rPr sz="3000" b="1">
+                <a:solidFill>
+                  <a:srgbClr val="1A2332"/>
+                </a:solidFill>
+                <a:latin typeface="Segoe UI"/>
+              </a:rPr>
+              <a:t>4%</a:t>
+            </a:r>
+          </a:p>
+        </p:txBody>
+      </p:sp>
+      <p:sp>
+        <p:nvSpPr>
+          <p:cNvPr id="21" name="TextBox 20"/>
+          <p:cNvSpPr txBox="1"/>
+          <p:nvPr/>
+        </p:nvSpPr>
+        <p:spPr>
+          <a:xfrm>
+            <a:off x="5095036" y="3172968"/>
+            <a:ext cx="1998878" cy="320040"/>
+          </a:xfrm>
+          <a:prstGeom prst="rect">
+            <a:avLst/>
+          </a:prstGeom>
+          <a:noFill/>
+        </p:spPr>
+        <p:txBody>
+          <a:bodyPr wrap="square" anchor="ctr" lIns="0" rIns="0" tIns="0" bIns="0">
+            <a:spAutoFit/>
+          </a:bodyPr>
+          <a:lstStyle/>
+          <a:p>
+            <a:pPr algn="ctr"/>
+            <a:r>
+              <a:rPr sz="1200" b="0">
+                <a:solidFill>
+                  <a:srgbClr val="5E665E"/>
+                </a:solidFill>
+                <a:latin typeface="Segoe UI"/>
+              </a:rPr>
+              <a:t>target 30%</a:t>
+            </a:r>
+          </a:p>
+        </p:txBody>
+      </p:sp>
+      <p:sp>
+        <p:nvSpPr>
+          <p:cNvPr id="22" name="Rounded Rectangle 21"/>
           <p:cNvSpPr/>
           <p:nvPr/>
         </p:nvSpPr>
         <p:spPr>
           <a:xfrm>
-            <a:off x="640080" y="4389120"/>
-            <a:ext cx="10908792" cy="731520"/>
+            <a:off x="7322515" y="1874519"/>
+            <a:ext cx="1998878" cy="1691640"/>
           </a:xfrm>
           <a:prstGeom prst="roundRect">
             <a:avLst/>
@@ -8152,14 +8624,14 @@
       </p:sp>
       <p:sp>
         <p:nvSpPr>
-          <p:cNvPr id="20" name="TextBox 19"/>
+          <p:cNvPr id="23" name="TextBox 22"/>
           <p:cNvSpPr txBox="1"/>
           <p:nvPr/>
         </p:nvSpPr>
         <p:spPr>
           <a:xfrm>
-            <a:off x="1005840" y="4389120"/>
-            <a:ext cx="8074151" cy="731520"/>
+            <a:off x="7322515" y="2075688"/>
+            <a:ext cx="1998878" cy="365760"/>
           </a:xfrm>
           <a:prstGeom prst="rect">
             <a:avLst/>
@@ -8172,44 +8644,35 @@
           </a:bodyPr>
           <a:lstStyle/>
           <a:p>
-            <a:pPr algn="l"/>
-            <a:r>
-              <a:rPr sz="1650" b="1">
-                <a:solidFill>
-                  <a:srgbClr val="1A2332"/>
-                </a:solidFill>
-                <a:latin typeface="Segoe UI"/>
-              </a:rPr>
-              <a:t>New hire    </a:t>
-            </a:r>
-            <a:r>
-              <a:rPr sz="1300" b="0">
+            <a:pPr algn="ctr"/>
+            <a:r>
+              <a:rPr sz="1350" b="1">
                 <a:solidFill>
                   <a:srgbClr val="5E665E"/>
                 </a:solidFill>
                 <a:latin typeface="Segoe UI"/>
               </a:rPr>
-              <a:t>First 40 appointments or 8 months</a:t>
-            </a:r>
-          </a:p>
-        </p:txBody>
-      </p:sp>
-      <p:sp>
-        <p:nvSpPr>
-          <p:cNvPr id="21" name="Rounded Rectangle 20"/>
+              <a:t>Pricing</a:t>
+            </a:r>
+          </a:p>
+        </p:txBody>
+      </p:sp>
+      <p:sp>
+        <p:nvSpPr>
+          <p:cNvPr id="24" name="Rounded Rectangle 23"/>
           <p:cNvSpPr/>
           <p:nvPr/>
         </p:nvSpPr>
         <p:spPr>
           <a:xfrm>
-            <a:off x="9281159" y="4507992"/>
-            <a:ext cx="2103120" cy="493776"/>
+            <a:off x="7887614" y="2441448"/>
+            <a:ext cx="868680" cy="64008"/>
           </a:xfrm>
           <a:prstGeom prst="roundRect">
             <a:avLst/>
           </a:prstGeom>
           <a:solidFill>
-            <a:srgbClr val="5EBA28"/>
+            <a:srgbClr val="29A9E1"/>
           </a:solidFill>
           <a:ln>
             <a:noFill/>
@@ -8240,14 +8703,14 @@
       </p:sp>
       <p:sp>
         <p:nvSpPr>
-          <p:cNvPr id="22" name="TextBox 21"/>
+          <p:cNvPr id="25" name="TextBox 24"/>
           <p:cNvSpPr txBox="1"/>
           <p:nvPr/>
         </p:nvSpPr>
         <p:spPr>
           <a:xfrm>
-            <a:off x="9281159" y="4507992"/>
-            <a:ext cx="2103120" cy="493776"/>
+            <a:off x="7322515" y="2587752"/>
+            <a:ext cx="1998878" cy="548640"/>
           </a:xfrm>
           <a:prstGeom prst="rect">
             <a:avLst/>
@@ -8262,27 +8725,62 @@
           <a:p>
             <a:pPr algn="ctr"/>
             <a:r>
-              <a:rPr sz="1500" b="1">
-                <a:solidFill>
-                  <a:srgbClr val="FFFFFF"/>
-                </a:solidFill>
-                <a:latin typeface="Segoe UI"/>
-              </a:rPr>
-              <a:t>At least 3</a:t>
-            </a:r>
-          </a:p>
-        </p:txBody>
-      </p:sp>
-      <p:sp>
-        <p:nvSpPr>
-          <p:cNvPr id="23" name="Rounded Rectangle 22"/>
+              <a:rPr sz="3000" b="1">
+                <a:solidFill>
+                  <a:srgbClr val="1A2332"/>
+                </a:solidFill>
+                <a:latin typeface="Segoe UI"/>
+              </a:rPr>
+              <a:t>79%</a:t>
+            </a:r>
+          </a:p>
+        </p:txBody>
+      </p:sp>
+      <p:sp>
+        <p:nvSpPr>
+          <p:cNvPr id="26" name="TextBox 25"/>
+          <p:cNvSpPr txBox="1"/>
+          <p:nvPr/>
+        </p:nvSpPr>
+        <p:spPr>
+          <a:xfrm>
+            <a:off x="7322515" y="3172968"/>
+            <a:ext cx="1998878" cy="320040"/>
+          </a:xfrm>
+          <a:prstGeom prst="rect">
+            <a:avLst/>
+          </a:prstGeom>
+          <a:noFill/>
+        </p:spPr>
+        <p:txBody>
+          <a:bodyPr wrap="square" anchor="ctr" lIns="0" rIns="0" tIns="0" bIns="0">
+            <a:spAutoFit/>
+          </a:bodyPr>
+          <a:lstStyle/>
+          <a:p>
+            <a:pPr algn="ctr"/>
+            <a:r>
+              <a:rPr sz="1200" b="0">
+                <a:solidFill>
+                  <a:srgbClr val="5E665E"/>
+                </a:solidFill>
+                <a:latin typeface="Segoe UI"/>
+              </a:rPr>
+              <a:t>target 100%</a:t>
+            </a:r>
+          </a:p>
+        </p:txBody>
+      </p:sp>
+      <p:sp>
+        <p:nvSpPr>
+          <p:cNvPr id="27" name="Rounded Rectangle 26"/>
           <p:cNvSpPr/>
           <p:nvPr/>
         </p:nvSpPr>
         <p:spPr>
           <a:xfrm>
-            <a:off x="640080" y="5248656"/>
-            <a:ext cx="10908792" cy="731520"/>
+            <a:off x="9549993" y="1874519"/>
+            <a:ext cx="1998878" cy="1691640"/>
           </a:xfrm>
           <a:prstGeom prst="roundRect">
             <a:avLst/>
@@ -8321,14 +8819,14 @@
       </p:sp>
       <p:sp>
         <p:nvSpPr>
-          <p:cNvPr id="24" name="TextBox 23"/>
+          <p:cNvPr id="28" name="TextBox 27"/>
           <p:cNvSpPr txBox="1"/>
           <p:nvPr/>
         </p:nvSpPr>
         <p:spPr>
           <a:xfrm>
-            <a:off x="1005840" y="5248656"/>
-            <a:ext cx="8074151" cy="731520"/>
+            <a:off x="9549993" y="2075688"/>
+            <a:ext cx="1998878" cy="365760"/>
           </a:xfrm>
           <a:prstGeom prst="rect">
             <a:avLst/>
@@ -8341,44 +8839,35 @@
           </a:bodyPr>
           <a:lstStyle/>
           <a:p>
-            <a:pPr algn="l"/>
-            <a:r>
-              <a:rPr sz="1650" b="1">
-                <a:solidFill>
-                  <a:srgbClr val="1A2332"/>
-                </a:solidFill>
-                <a:latin typeface="Segoe UI"/>
-              </a:rPr>
-              <a:t>Low volume    </a:t>
-            </a:r>
-            <a:r>
-              <a:rPr sz="1300" b="0">
+            <a:pPr algn="ctr"/>
+            <a:r>
+              <a:rPr sz="1350" b="1">
                 <a:solidFill>
                   <a:srgbClr val="5E665E"/>
                 </a:solidFill>
                 <a:latin typeface="Segoe UI"/>
               </a:rPr>
-              <a:t>Too few at-bats (under 15 / 20 / 30 by channel)</a:t>
-            </a:r>
-          </a:p>
-        </p:txBody>
-      </p:sp>
-      <p:sp>
-        <p:nvSpPr>
-          <p:cNvPr id="25" name="Rounded Rectangle 24"/>
+              <a:t>Self-gen</a:t>
+            </a:r>
+          </a:p>
+        </p:txBody>
+      </p:sp>
+      <p:sp>
+        <p:nvSpPr>
+          <p:cNvPr id="29" name="Rounded Rectangle 28"/>
           <p:cNvSpPr/>
           <p:nvPr/>
         </p:nvSpPr>
         <p:spPr>
           <a:xfrm>
-            <a:off x="9281159" y="5367528"/>
-            <a:ext cx="2103120" cy="493776"/>
+            <a:off x="10115092" y="2441448"/>
+            <a:ext cx="868680" cy="64008"/>
           </a:xfrm>
           <a:prstGeom prst="roundRect">
             <a:avLst/>
           </a:prstGeom>
           <a:solidFill>
-            <a:srgbClr val="5E665E"/>
+            <a:srgbClr val="29A9E1"/>
           </a:solidFill>
           <a:ln>
             <a:noFill/>
@@ -8409,14 +8898,14 @@
       </p:sp>
       <p:sp>
         <p:nvSpPr>
-          <p:cNvPr id="26" name="TextBox 25"/>
+          <p:cNvPr id="30" name="TextBox 29"/>
           <p:cNvSpPr txBox="1"/>
           <p:nvPr/>
         </p:nvSpPr>
         <p:spPr>
           <a:xfrm>
-            <a:off x="9281159" y="5367528"/>
-            <a:ext cx="2103120" cy="493776"/>
+            <a:off x="9549993" y="2587752"/>
+            <a:ext cx="1998878" cy="548640"/>
           </a:xfrm>
           <a:prstGeom prst="rect">
             <a:avLst/>
@@ -8431,27 +8920,62 @@
           <a:p>
             <a:pPr algn="ctr"/>
             <a:r>
-              <a:rPr sz="1500" b="1">
-                <a:solidFill>
-                  <a:srgbClr val="FFFFFF"/>
-                </a:solidFill>
-                <a:latin typeface="Segoe UI"/>
-              </a:rPr>
-              <a:t>Caps at 4</a:t>
-            </a:r>
-          </a:p>
-        </p:txBody>
-      </p:sp>
-      <p:sp>
-        <p:nvSpPr>
-          <p:cNvPr id="27" name="TextBox 26"/>
+              <a:rPr sz="3000" b="1">
+                <a:solidFill>
+                  <a:srgbClr val="1A2332"/>
+                </a:solidFill>
+                <a:latin typeface="Segoe UI"/>
+              </a:rPr>
+              <a:t>22%</a:t>
+            </a:r>
+          </a:p>
+        </p:txBody>
+      </p:sp>
+      <p:sp>
+        <p:nvSpPr>
+          <p:cNvPr id="31" name="TextBox 30"/>
           <p:cNvSpPr txBox="1"/>
           <p:nvPr/>
         </p:nvSpPr>
         <p:spPr>
           <a:xfrm>
-            <a:off x="640080" y="6144768"/>
-            <a:ext cx="10908792" cy="365760"/>
+            <a:off x="9549993" y="3172968"/>
+            <a:ext cx="1998878" cy="320040"/>
+          </a:xfrm>
+          <a:prstGeom prst="rect">
+            <a:avLst/>
+          </a:prstGeom>
+          <a:noFill/>
+        </p:spPr>
+        <p:txBody>
+          <a:bodyPr wrap="square" anchor="ctr" lIns="0" rIns="0" tIns="0" bIns="0">
+            <a:spAutoFit/>
+          </a:bodyPr>
+          <a:lstStyle/>
+          <a:p>
+            <a:pPr algn="ctr"/>
+            <a:r>
+              <a:rPr sz="1200" b="0">
+                <a:solidFill>
+                  <a:srgbClr val="5E665E"/>
+                </a:solidFill>
+                <a:latin typeface="Segoe UI"/>
+              </a:rPr>
+              <a:t>target 75%</a:t>
+            </a:r>
+          </a:p>
+        </p:txBody>
+      </p:sp>
+      <p:sp>
+        <p:nvSpPr>
+          <p:cNvPr id="32" name="TextBox 31"/>
+          <p:cNvSpPr txBox="1"/>
+          <p:nvPr/>
+        </p:nvSpPr>
+        <p:spPr>
+          <a:xfrm>
+            <a:off x="640080" y="3611879"/>
+            <a:ext cx="10908792" cy="320040"/>
           </a:xfrm>
           <a:prstGeom prst="rect">
             <a:avLst/>
@@ -8464,15 +8988,353 @@
           </a:bodyPr>
           <a:lstStyle/>
           <a:p>
+            <a:pPr algn="ctr"/>
+            <a:r>
+              <a:rPr sz="1250" b="0">
+                <a:solidFill>
+                  <a:srgbClr val="5E665E"/>
+                </a:solidFill>
+                <a:latin typeface="Segoe UI"/>
+              </a:rPr>
+              <a:t>Each number is scored against its target, then weighted. Near target on the big two is what carries the score.</a:t>
+            </a:r>
+          </a:p>
+        </p:txBody>
+      </p:sp>
+      <p:sp>
+        <p:nvSpPr>
+          <p:cNvPr id="33" name="Rounded Rectangle 32"/>
+          <p:cNvSpPr/>
+          <p:nvPr/>
+        </p:nvSpPr>
+        <p:spPr>
+          <a:xfrm>
+            <a:off x="640080" y="4160520"/>
+            <a:ext cx="10908792" cy="960120"/>
+          </a:xfrm>
+          <a:prstGeom prst="roundRect">
+            <a:avLst/>
+          </a:prstGeom>
+          <a:solidFill>
+            <a:srgbClr val="1A2332"/>
+          </a:solidFill>
+          <a:ln>
+            <a:noFill/>
+          </a:ln>
+          <a:effectLst/>
+        </p:spPr>
+        <p:style>
+          <a:lnRef idx="1">
+            <a:schemeClr val="accent1"/>
+          </a:lnRef>
+          <a:fillRef idx="3">
+            <a:schemeClr val="accent1"/>
+          </a:fillRef>
+          <a:effectRef idx="2">
+            <a:schemeClr val="accent1"/>
+          </a:effectRef>
+          <a:fontRef idx="minor">
+            <a:schemeClr val="lt1"/>
+          </a:fontRef>
+        </p:style>
+        <p:txBody>
+          <a:bodyPr rtlCol="0" anchor="ctr"/>
+          <a:lstStyle/>
+          <a:p>
+            <a:pPr algn="ctr"/>
+          </a:p>
+        </p:txBody>
+      </p:sp>
+      <p:sp>
+        <p:nvSpPr>
+          <p:cNvPr id="34" name="TextBox 33"/>
+          <p:cNvSpPr txBox="1"/>
+          <p:nvPr/>
+        </p:nvSpPr>
+        <p:spPr>
+          <a:xfrm>
+            <a:off x="1097280" y="4160520"/>
+            <a:ext cx="4572000" cy="960120"/>
+          </a:xfrm>
+          <a:prstGeom prst="rect">
+            <a:avLst/>
+          </a:prstGeom>
+          <a:noFill/>
+        </p:spPr>
+        <p:txBody>
+          <a:bodyPr wrap="square" anchor="ctr" lIns="0" rIns="0" tIns="0" bIns="0">
+            <a:spAutoFit/>
+          </a:bodyPr>
+          <a:lstStyle/>
+          <a:p>
             <a:pPr algn="l"/>
             <a:r>
+              <a:rPr sz="1800" b="0">
+                <a:solidFill>
+                  <a:srgbClr val="C9D2C4"/>
+                </a:solidFill>
+                <a:latin typeface="Segoe UI"/>
+              </a:rPr>
+              <a:t>Viper score   </a:t>
+            </a:r>
+            <a:r>
+              <a:rPr sz="4000" b="1">
+                <a:solidFill>
+                  <a:srgbClr val="FFFFFF"/>
+                </a:solidFill>
+                <a:latin typeface="Segoe UI"/>
+              </a:rPr>
+              <a:t>79</a:t>
+            </a:r>
+          </a:p>
+        </p:txBody>
+      </p:sp>
+      <p:sp>
+        <p:nvSpPr>
+          <p:cNvPr id="35" name="Rounded Rectangle 34"/>
+          <p:cNvSpPr/>
+          <p:nvPr/>
+        </p:nvSpPr>
+        <p:spPr>
+          <a:xfrm>
+            <a:off x="6766560" y="4343400"/>
+            <a:ext cx="2011680" cy="594360"/>
+          </a:xfrm>
+          <a:prstGeom prst="roundRect">
+            <a:avLst/>
+          </a:prstGeom>
+          <a:solidFill>
+            <a:srgbClr val="5EBA28"/>
+          </a:solidFill>
+          <a:ln>
+            <a:noFill/>
+          </a:ln>
+          <a:effectLst/>
+        </p:spPr>
+        <p:style>
+          <a:lnRef idx="1">
+            <a:schemeClr val="accent1"/>
+          </a:lnRef>
+          <a:fillRef idx="3">
+            <a:schemeClr val="accent1"/>
+          </a:fillRef>
+          <a:effectRef idx="2">
+            <a:schemeClr val="accent1"/>
+          </a:effectRef>
+          <a:fontRef idx="minor">
+            <a:schemeClr val="lt1"/>
+          </a:fontRef>
+        </p:style>
+        <p:txBody>
+          <a:bodyPr rtlCol="0" anchor="ctr"/>
+          <a:lstStyle/>
+          <a:p>
+            <a:pPr algn="ctr"/>
+          </a:p>
+        </p:txBody>
+      </p:sp>
+      <p:sp>
+        <p:nvSpPr>
+          <p:cNvPr id="36" name="TextBox 35"/>
+          <p:cNvSpPr txBox="1"/>
+          <p:nvPr/>
+        </p:nvSpPr>
+        <p:spPr>
+          <a:xfrm>
+            <a:off x="6766560" y="4343400"/>
+            <a:ext cx="2011680" cy="594360"/>
+          </a:xfrm>
+          <a:prstGeom prst="rect">
+            <a:avLst/>
+          </a:prstGeom>
+          <a:noFill/>
+        </p:spPr>
+        <p:txBody>
+          <a:bodyPr wrap="square" anchor="ctr" lIns="0" rIns="0" tIns="0" bIns="0">
+            <a:spAutoFit/>
+          </a:bodyPr>
+          <a:lstStyle/>
+          <a:p>
+            <a:pPr algn="ctr"/>
+            <a:r>
+              <a:rPr sz="2400" b="1">
+                <a:solidFill>
+                  <a:srgbClr val="FFFFFF"/>
+                </a:solidFill>
+                <a:latin typeface="Segoe UI"/>
+              </a:rPr>
+              <a:t>Rank 4</a:t>
+            </a:r>
+          </a:p>
+        </p:txBody>
+      </p:sp>
+      <p:sp>
+        <p:nvSpPr>
+          <p:cNvPr id="37" name="TextBox 36"/>
+          <p:cNvSpPr txBox="1"/>
+          <p:nvPr/>
+        </p:nvSpPr>
+        <p:spPr>
+          <a:xfrm>
+            <a:off x="8961119" y="4160520"/>
+            <a:ext cx="2468880" cy="960120"/>
+          </a:xfrm>
+          <a:prstGeom prst="rect">
+            <a:avLst/>
+          </a:prstGeom>
+          <a:noFill/>
+        </p:spPr>
+        <p:txBody>
+          <a:bodyPr wrap="square" anchor="ctr" lIns="0" rIns="0" tIns="0" bIns="0">
+            <a:spAutoFit/>
+          </a:bodyPr>
+          <a:lstStyle/>
+          <a:p>
+            <a:pPr algn="l">
+              <a:spcAft>
+                <a:spcPts val="200"/>
+              </a:spcAft>
+            </a:pPr>
+            <a:r>
+              <a:rPr sz="1600" b="1">
+                <a:solidFill>
+                  <a:srgbClr val="FFFFFF"/>
+                </a:solidFill>
+                <a:latin typeface="Segoe UI"/>
+              </a:rPr>
+              <a:t>up from 3</a:t>
+            </a:r>
+          </a:p>
+          <a:p>
+            <a:pPr algn="l">
+              <a:spcAft>
+                <a:spcPts val="200"/>
+              </a:spcAft>
+            </a:pPr>
+            <a:r>
               <a:rPr sz="1250" b="0">
                 <a:solidFill>
+                  <a:srgbClr val="C9D2C4"/>
+                </a:solidFill>
+                <a:latin typeface="Segoe UI"/>
+              </a:rPr>
+              <a:t>the week before</a:t>
+            </a:r>
+          </a:p>
+        </p:txBody>
+      </p:sp>
+      <p:sp>
+        <p:nvSpPr>
+          <p:cNvPr id="38" name="TextBox 37"/>
+          <p:cNvSpPr txBox="1"/>
+          <p:nvPr/>
+        </p:nvSpPr>
+        <p:spPr>
+          <a:xfrm>
+            <a:off x="640080" y="5349240"/>
+            <a:ext cx="10908792" cy="457200"/>
+          </a:xfrm>
+          <a:prstGeom prst="rect">
+            <a:avLst/>
+          </a:prstGeom>
+          <a:noFill/>
+        </p:spPr>
+        <p:txBody>
+          <a:bodyPr wrap="square" anchor="t" lIns="0" rIns="0" tIns="0" bIns="0">
+            <a:spAutoFit/>
+          </a:bodyPr>
+          <a:lstStyle/>
+          <a:p>
+            <a:pPr algn="ctr"/>
+            <a:r>
+              <a:rPr sz="1500" b="1">
+                <a:solidFill>
+                  <a:srgbClr val="1A2332"/>
+                </a:solidFill>
+                <a:latin typeface="Segoe UI"/>
+              </a:rPr>
+              <a:t>Closes and installs our leads well, which is the 80% that counts. Attachment is the gap. Net: a solid rank 4.</a:t>
+            </a:r>
+          </a:p>
+        </p:txBody>
+      </p:sp>
+      <p:sp>
+        <p:nvSpPr>
+          <p:cNvPr id="39" name="Rounded Rectangle 38"/>
+          <p:cNvSpPr/>
+          <p:nvPr/>
+        </p:nvSpPr>
+        <p:spPr>
+          <a:xfrm>
+            <a:off x="640080" y="5989320"/>
+            <a:ext cx="10908792" cy="548640"/>
+          </a:xfrm>
+          <a:prstGeom prst="roundRect">
+            <a:avLst/>
+          </a:prstGeom>
+          <a:solidFill>
+            <a:srgbClr val="EFF1EC"/>
+          </a:solidFill>
+          <a:ln w="9525">
+            <a:solidFill>
+              <a:srgbClr val="D8DDD4"/>
+            </a:solidFill>
+          </a:ln>
+          <a:effectLst/>
+        </p:spPr>
+        <p:style>
+          <a:lnRef idx="1">
+            <a:schemeClr val="accent1"/>
+          </a:lnRef>
+          <a:fillRef idx="3">
+            <a:schemeClr val="accent1"/>
+          </a:fillRef>
+          <a:effectRef idx="2">
+            <a:schemeClr val="accent1"/>
+          </a:effectRef>
+          <a:fontRef idx="minor">
+            <a:schemeClr val="lt1"/>
+          </a:fontRef>
+        </p:style>
+        <p:txBody>
+          <a:bodyPr rtlCol="0" anchor="ctr"/>
+          <a:lstStyle/>
+          <a:p>
+            <a:pPr algn="ctr"/>
+          </a:p>
+        </p:txBody>
+      </p:sp>
+      <p:sp>
+        <p:nvSpPr>
+          <p:cNvPr id="40" name="TextBox 39"/>
+          <p:cNvSpPr txBox="1"/>
+          <p:nvPr/>
+        </p:nvSpPr>
+        <p:spPr>
+          <a:xfrm>
+            <a:off x="914400" y="5989320"/>
+            <a:ext cx="10360152" cy="548640"/>
+          </a:xfrm>
+          <a:prstGeom prst="rect">
+            <a:avLst/>
+          </a:prstGeom>
+          <a:noFill/>
+        </p:spPr>
+        <p:txBody>
+          <a:bodyPr wrap="square" anchor="ctr" lIns="0" rIns="0" tIns="0" bIns="0">
+            <a:spAutoFit/>
+          </a:bodyPr>
+          <a:lstStyle/>
+          <a:p>
+            <a:pPr algn="l"/>
+            <a:r>
+              <a:rPr sz="1200" b="0">
+                <a:solidFill>
                   <a:srgbClr val="5E665E"/>
                 </a:solidFill>
                 <a:latin typeface="Segoe UI"/>
               </a:rPr>
-              <a:t>A floor is a minimum, not a ceiling. Earn higher and you keep it. Only Hall of Fame is automatic.</a:t>
+              <a:t>Latest run: dispatched appointments read Mar 7 to May 22, installs measured on deals signed Jun 2025 to Feb 2026.</a:t>
             </a:r>
           </a:p>
         </p:txBody>
@@ -8657,1574 +9519,6 @@
                 </a:solidFill>
                 <a:latin typeface="Segoe UI"/>
               </a:rPr>
-              <a:t>In practice: one rep, one week</a:t>
-            </a:r>
-          </a:p>
-        </p:txBody>
-      </p:sp>
-      <p:sp>
-        <p:nvSpPr>
-          <p:cNvPr id="6" name="TextBox 5"/>
-          <p:cNvSpPr txBox="1"/>
-          <p:nvPr/>
-        </p:nvSpPr>
-        <p:spPr>
-          <a:xfrm>
-            <a:off x="640080" y="1170432"/>
-            <a:ext cx="10972800" cy="411480"/>
-          </a:xfrm>
-          <a:prstGeom prst="rect">
-            <a:avLst/>
-          </a:prstGeom>
-          <a:noFill/>
-        </p:spPr>
-        <p:txBody>
-          <a:bodyPr wrap="square" anchor="t" lIns="0" rIns="0" tIns="0" bIns="0">
-            <a:spAutoFit/>
-          </a:bodyPr>
-          <a:lstStyle/>
-          <a:p>
-            <a:pPr algn="l"/>
-            <a:r>
-              <a:rPr sz="1400" b="0">
-                <a:solidFill>
-                  <a:srgbClr val="5E665E"/>
-                </a:solidFill>
-                <a:latin typeface="Segoe UI"/>
-              </a:rPr>
-              <a:t>Real numbers from the last run, name withheld.</a:t>
-            </a:r>
-          </a:p>
-        </p:txBody>
-      </p:sp>
-      <p:sp>
-        <p:nvSpPr>
-          <p:cNvPr id="7" name="Rounded Rectangle 6"/>
-          <p:cNvSpPr/>
-          <p:nvPr/>
-        </p:nvSpPr>
-        <p:spPr>
-          <a:xfrm>
-            <a:off x="640080" y="1874519"/>
-            <a:ext cx="1998878" cy="1691640"/>
-          </a:xfrm>
-          <a:prstGeom prst="roundRect">
-            <a:avLst/>
-          </a:prstGeom>
-          <a:solidFill>
-            <a:srgbClr val="EFF1EC"/>
-          </a:solidFill>
-          <a:ln w="9525">
-            <a:solidFill>
-              <a:srgbClr val="D8DDD4"/>
-            </a:solidFill>
-          </a:ln>
-          <a:effectLst/>
-        </p:spPr>
-        <p:style>
-          <a:lnRef idx="1">
-            <a:schemeClr val="accent1"/>
-          </a:lnRef>
-          <a:fillRef idx="3">
-            <a:schemeClr val="accent1"/>
-          </a:fillRef>
-          <a:effectRef idx="2">
-            <a:schemeClr val="accent1"/>
-          </a:effectRef>
-          <a:fontRef idx="minor">
-            <a:schemeClr val="lt1"/>
-          </a:fontRef>
-        </p:style>
-        <p:txBody>
-          <a:bodyPr rtlCol="0" anchor="ctr"/>
-          <a:lstStyle/>
-          <a:p>
-            <a:pPr algn="ctr"/>
-          </a:p>
-        </p:txBody>
-      </p:sp>
-      <p:sp>
-        <p:nvSpPr>
-          <p:cNvPr id="8" name="TextBox 7"/>
-          <p:cNvSpPr txBox="1"/>
-          <p:nvPr/>
-        </p:nvSpPr>
-        <p:spPr>
-          <a:xfrm>
-            <a:off x="640080" y="2075688"/>
-            <a:ext cx="1998878" cy="365760"/>
-          </a:xfrm>
-          <a:prstGeom prst="rect">
-            <a:avLst/>
-          </a:prstGeom>
-          <a:noFill/>
-        </p:spPr>
-        <p:txBody>
-          <a:bodyPr wrap="square" anchor="ctr" lIns="0" rIns="0" tIns="0" bIns="0">
-            <a:spAutoFit/>
-          </a:bodyPr>
-          <a:lstStyle/>
-          <a:p>
-            <a:pPr algn="ctr"/>
-            <a:r>
-              <a:rPr sz="1350" b="1">
-                <a:solidFill>
-                  <a:srgbClr val="5E665E"/>
-                </a:solidFill>
-                <a:latin typeface="Segoe UI"/>
-              </a:rPr>
-              <a:t>Effective</a:t>
-            </a:r>
-          </a:p>
-        </p:txBody>
-      </p:sp>
-      <p:sp>
-        <p:nvSpPr>
-          <p:cNvPr id="9" name="Rounded Rectangle 8"/>
-          <p:cNvSpPr/>
-          <p:nvPr/>
-        </p:nvSpPr>
-        <p:spPr>
-          <a:xfrm>
-            <a:off x="1205179" y="2441448"/>
-            <a:ext cx="868680" cy="64008"/>
-          </a:xfrm>
-          <a:prstGeom prst="roundRect">
-            <a:avLst/>
-          </a:prstGeom>
-          <a:solidFill>
-            <a:srgbClr val="5EBA28"/>
-          </a:solidFill>
-          <a:ln>
-            <a:noFill/>
-          </a:ln>
-          <a:effectLst/>
-        </p:spPr>
-        <p:style>
-          <a:lnRef idx="1">
-            <a:schemeClr val="accent1"/>
-          </a:lnRef>
-          <a:fillRef idx="3">
-            <a:schemeClr val="accent1"/>
-          </a:fillRef>
-          <a:effectRef idx="2">
-            <a:schemeClr val="accent1"/>
-          </a:effectRef>
-          <a:fontRef idx="minor">
-            <a:schemeClr val="lt1"/>
-          </a:fontRef>
-        </p:style>
-        <p:txBody>
-          <a:bodyPr rtlCol="0" anchor="ctr"/>
-          <a:lstStyle/>
-          <a:p>
-            <a:pPr algn="ctr"/>
-          </a:p>
-        </p:txBody>
-      </p:sp>
-      <p:sp>
-        <p:nvSpPr>
-          <p:cNvPr id="10" name="TextBox 9"/>
-          <p:cNvSpPr txBox="1"/>
-          <p:nvPr/>
-        </p:nvSpPr>
-        <p:spPr>
-          <a:xfrm>
-            <a:off x="640080" y="2587752"/>
-            <a:ext cx="1998878" cy="548640"/>
-          </a:xfrm>
-          <a:prstGeom prst="rect">
-            <a:avLst/>
-          </a:prstGeom>
-          <a:noFill/>
-        </p:spPr>
-        <p:txBody>
-          <a:bodyPr wrap="square" anchor="ctr" lIns="0" rIns="0" tIns="0" bIns="0">
-            <a:spAutoFit/>
-          </a:bodyPr>
-          <a:lstStyle/>
-          <a:p>
-            <a:pPr algn="ctr"/>
-            <a:r>
-              <a:rPr sz="3000" b="1">
-                <a:solidFill>
-                  <a:srgbClr val="1A2332"/>
-                </a:solidFill>
-                <a:latin typeface="Segoe UI"/>
-              </a:rPr>
-              <a:t>26%</a:t>
-            </a:r>
-          </a:p>
-        </p:txBody>
-      </p:sp>
-      <p:sp>
-        <p:nvSpPr>
-          <p:cNvPr id="11" name="TextBox 10"/>
-          <p:cNvSpPr txBox="1"/>
-          <p:nvPr/>
-        </p:nvSpPr>
-        <p:spPr>
-          <a:xfrm>
-            <a:off x="640080" y="3172968"/>
-            <a:ext cx="1998878" cy="320040"/>
-          </a:xfrm>
-          <a:prstGeom prst="rect">
-            <a:avLst/>
-          </a:prstGeom>
-          <a:noFill/>
-        </p:spPr>
-        <p:txBody>
-          <a:bodyPr wrap="square" anchor="ctr" lIns="0" rIns="0" tIns="0" bIns="0">
-            <a:spAutoFit/>
-          </a:bodyPr>
-          <a:lstStyle/>
-          <a:p>
-            <a:pPr algn="ctr"/>
-            <a:r>
-              <a:rPr sz="1200" b="0">
-                <a:solidFill>
-                  <a:srgbClr val="5E665E"/>
-                </a:solidFill>
-                <a:latin typeface="Segoe UI"/>
-              </a:rPr>
-              <a:t>target 30%</a:t>
-            </a:r>
-          </a:p>
-        </p:txBody>
-      </p:sp>
-      <p:sp>
-        <p:nvSpPr>
-          <p:cNvPr id="12" name="Rounded Rectangle 11"/>
-          <p:cNvSpPr/>
-          <p:nvPr/>
-        </p:nvSpPr>
-        <p:spPr>
-          <a:xfrm>
-            <a:off x="2867558" y="1874519"/>
-            <a:ext cx="1998878" cy="1691640"/>
-          </a:xfrm>
-          <a:prstGeom prst="roundRect">
-            <a:avLst/>
-          </a:prstGeom>
-          <a:solidFill>
-            <a:srgbClr val="EFF1EC"/>
-          </a:solidFill>
-          <a:ln w="9525">
-            <a:solidFill>
-              <a:srgbClr val="D8DDD4"/>
-            </a:solidFill>
-          </a:ln>
-          <a:effectLst/>
-        </p:spPr>
-        <p:style>
-          <a:lnRef idx="1">
-            <a:schemeClr val="accent1"/>
-          </a:lnRef>
-          <a:fillRef idx="3">
-            <a:schemeClr val="accent1"/>
-          </a:fillRef>
-          <a:effectRef idx="2">
-            <a:schemeClr val="accent1"/>
-          </a:effectRef>
-          <a:fontRef idx="minor">
-            <a:schemeClr val="lt1"/>
-          </a:fontRef>
-        </p:style>
-        <p:txBody>
-          <a:bodyPr rtlCol="0" anchor="ctr"/>
-          <a:lstStyle/>
-          <a:p>
-            <a:pPr algn="ctr"/>
-          </a:p>
-        </p:txBody>
-      </p:sp>
-      <p:sp>
-        <p:nvSpPr>
-          <p:cNvPr id="13" name="TextBox 12"/>
-          <p:cNvSpPr txBox="1"/>
-          <p:nvPr/>
-        </p:nvSpPr>
-        <p:spPr>
-          <a:xfrm>
-            <a:off x="2867558" y="2075688"/>
-            <a:ext cx="1998878" cy="365760"/>
-          </a:xfrm>
-          <a:prstGeom prst="rect">
-            <a:avLst/>
-          </a:prstGeom>
-          <a:noFill/>
-        </p:spPr>
-        <p:txBody>
-          <a:bodyPr wrap="square" anchor="ctr" lIns="0" rIns="0" tIns="0" bIns="0">
-            <a:spAutoFit/>
-          </a:bodyPr>
-          <a:lstStyle/>
-          <a:p>
-            <a:pPr algn="ctr"/>
-            <a:r>
-              <a:rPr sz="1350" b="1">
-                <a:solidFill>
-                  <a:srgbClr val="5E665E"/>
-                </a:solidFill>
-                <a:latin typeface="Segoe UI"/>
-              </a:rPr>
-              <a:t>Pull-through</a:t>
-            </a:r>
-          </a:p>
-        </p:txBody>
-      </p:sp>
-      <p:sp>
-        <p:nvSpPr>
-          <p:cNvPr id="14" name="Rounded Rectangle 13"/>
-          <p:cNvSpPr/>
-          <p:nvPr/>
-        </p:nvSpPr>
-        <p:spPr>
-          <a:xfrm>
-            <a:off x="3432657" y="2441448"/>
-            <a:ext cx="868680" cy="64008"/>
-          </a:xfrm>
-          <a:prstGeom prst="roundRect">
-            <a:avLst/>
-          </a:prstGeom>
-          <a:solidFill>
-            <a:srgbClr val="5EBA28"/>
-          </a:solidFill>
-          <a:ln>
-            <a:noFill/>
-          </a:ln>
-          <a:effectLst/>
-        </p:spPr>
-        <p:style>
-          <a:lnRef idx="1">
-            <a:schemeClr val="accent1"/>
-          </a:lnRef>
-          <a:fillRef idx="3">
-            <a:schemeClr val="accent1"/>
-          </a:fillRef>
-          <a:effectRef idx="2">
-            <a:schemeClr val="accent1"/>
-          </a:effectRef>
-          <a:fontRef idx="minor">
-            <a:schemeClr val="lt1"/>
-          </a:fontRef>
-        </p:style>
-        <p:txBody>
-          <a:bodyPr rtlCol="0" anchor="ctr"/>
-          <a:lstStyle/>
-          <a:p>
-            <a:pPr algn="ctr"/>
-          </a:p>
-        </p:txBody>
-      </p:sp>
-      <p:sp>
-        <p:nvSpPr>
-          <p:cNvPr id="15" name="TextBox 14"/>
-          <p:cNvSpPr txBox="1"/>
-          <p:nvPr/>
-        </p:nvSpPr>
-        <p:spPr>
-          <a:xfrm>
-            <a:off x="2867558" y="2587752"/>
-            <a:ext cx="1998878" cy="548640"/>
-          </a:xfrm>
-          <a:prstGeom prst="rect">
-            <a:avLst/>
-          </a:prstGeom>
-          <a:noFill/>
-        </p:spPr>
-        <p:txBody>
-          <a:bodyPr wrap="square" anchor="ctr" lIns="0" rIns="0" tIns="0" bIns="0">
-            <a:spAutoFit/>
-          </a:bodyPr>
-          <a:lstStyle/>
-          <a:p>
-            <a:pPr algn="ctr"/>
-            <a:r>
-              <a:rPr sz="3000" b="1">
-                <a:solidFill>
-                  <a:srgbClr val="1A2332"/>
-                </a:solidFill>
-                <a:latin typeface="Segoe UI"/>
-              </a:rPr>
-              <a:t>78%</a:t>
-            </a:r>
-          </a:p>
-        </p:txBody>
-      </p:sp>
-      <p:sp>
-        <p:nvSpPr>
-          <p:cNvPr id="16" name="TextBox 15"/>
-          <p:cNvSpPr txBox="1"/>
-          <p:nvPr/>
-        </p:nvSpPr>
-        <p:spPr>
-          <a:xfrm>
-            <a:off x="2867558" y="3172968"/>
-            <a:ext cx="1998878" cy="320040"/>
-          </a:xfrm>
-          <a:prstGeom prst="rect">
-            <a:avLst/>
-          </a:prstGeom>
-          <a:noFill/>
-        </p:spPr>
-        <p:txBody>
-          <a:bodyPr wrap="square" anchor="ctr" lIns="0" rIns="0" tIns="0" bIns="0">
-            <a:spAutoFit/>
-          </a:bodyPr>
-          <a:lstStyle/>
-          <a:p>
-            <a:pPr algn="ctr"/>
-            <a:r>
-              <a:rPr sz="1200" b="0">
-                <a:solidFill>
-                  <a:srgbClr val="5E665E"/>
-                </a:solidFill>
-                <a:latin typeface="Segoe UI"/>
-              </a:rPr>
-              <a:t>target 80%</a:t>
-            </a:r>
-          </a:p>
-        </p:txBody>
-      </p:sp>
-      <p:sp>
-        <p:nvSpPr>
-          <p:cNvPr id="17" name="Rounded Rectangle 16"/>
-          <p:cNvSpPr/>
-          <p:nvPr/>
-        </p:nvSpPr>
-        <p:spPr>
-          <a:xfrm>
-            <a:off x="5095036" y="1874519"/>
-            <a:ext cx="1998878" cy="1691640"/>
-          </a:xfrm>
-          <a:prstGeom prst="roundRect">
-            <a:avLst/>
-          </a:prstGeom>
-          <a:solidFill>
-            <a:srgbClr val="EFF1EC"/>
-          </a:solidFill>
-          <a:ln w="9525">
-            <a:solidFill>
-              <a:srgbClr val="D8DDD4"/>
-            </a:solidFill>
-          </a:ln>
-          <a:effectLst/>
-        </p:spPr>
-        <p:style>
-          <a:lnRef idx="1">
-            <a:schemeClr val="accent1"/>
-          </a:lnRef>
-          <a:fillRef idx="3">
-            <a:schemeClr val="accent1"/>
-          </a:fillRef>
-          <a:effectRef idx="2">
-            <a:schemeClr val="accent1"/>
-          </a:effectRef>
-          <a:fontRef idx="minor">
-            <a:schemeClr val="lt1"/>
-          </a:fontRef>
-        </p:style>
-        <p:txBody>
-          <a:bodyPr rtlCol="0" anchor="ctr"/>
-          <a:lstStyle/>
-          <a:p>
-            <a:pPr algn="ctr"/>
-          </a:p>
-        </p:txBody>
-      </p:sp>
-      <p:sp>
-        <p:nvSpPr>
-          <p:cNvPr id="18" name="TextBox 17"/>
-          <p:cNvSpPr txBox="1"/>
-          <p:nvPr/>
-        </p:nvSpPr>
-        <p:spPr>
-          <a:xfrm>
-            <a:off x="5095036" y="2075688"/>
-            <a:ext cx="1998878" cy="365760"/>
-          </a:xfrm>
-          <a:prstGeom prst="rect">
-            <a:avLst/>
-          </a:prstGeom>
-          <a:noFill/>
-        </p:spPr>
-        <p:txBody>
-          <a:bodyPr wrap="square" anchor="ctr" lIns="0" rIns="0" tIns="0" bIns="0">
-            <a:spAutoFit/>
-          </a:bodyPr>
-          <a:lstStyle/>
-          <a:p>
-            <a:pPr algn="ctr"/>
-            <a:r>
-              <a:rPr sz="1350" b="1">
-                <a:solidFill>
-                  <a:srgbClr val="5E665E"/>
-                </a:solidFill>
-                <a:latin typeface="Segoe UI"/>
-              </a:rPr>
-              <a:t>Attachment</a:t>
-            </a:r>
-          </a:p>
-        </p:txBody>
-      </p:sp>
-      <p:sp>
-        <p:nvSpPr>
-          <p:cNvPr id="19" name="Rounded Rectangle 18"/>
-          <p:cNvSpPr/>
-          <p:nvPr/>
-        </p:nvSpPr>
-        <p:spPr>
-          <a:xfrm>
-            <a:off x="5660136" y="2441448"/>
-            <a:ext cx="868680" cy="64008"/>
-          </a:xfrm>
-          <a:prstGeom prst="roundRect">
-            <a:avLst/>
-          </a:prstGeom>
-          <a:solidFill>
-            <a:srgbClr val="29A9E1"/>
-          </a:solidFill>
-          <a:ln>
-            <a:noFill/>
-          </a:ln>
-          <a:effectLst/>
-        </p:spPr>
-        <p:style>
-          <a:lnRef idx="1">
-            <a:schemeClr val="accent1"/>
-          </a:lnRef>
-          <a:fillRef idx="3">
-            <a:schemeClr val="accent1"/>
-          </a:fillRef>
-          <a:effectRef idx="2">
-            <a:schemeClr val="accent1"/>
-          </a:effectRef>
-          <a:fontRef idx="minor">
-            <a:schemeClr val="lt1"/>
-          </a:fontRef>
-        </p:style>
-        <p:txBody>
-          <a:bodyPr rtlCol="0" anchor="ctr"/>
-          <a:lstStyle/>
-          <a:p>
-            <a:pPr algn="ctr"/>
-          </a:p>
-        </p:txBody>
-      </p:sp>
-      <p:sp>
-        <p:nvSpPr>
-          <p:cNvPr id="20" name="TextBox 19"/>
-          <p:cNvSpPr txBox="1"/>
-          <p:nvPr/>
-        </p:nvSpPr>
-        <p:spPr>
-          <a:xfrm>
-            <a:off x="5095036" y="2587752"/>
-            <a:ext cx="1998878" cy="548640"/>
-          </a:xfrm>
-          <a:prstGeom prst="rect">
-            <a:avLst/>
-          </a:prstGeom>
-          <a:noFill/>
-        </p:spPr>
-        <p:txBody>
-          <a:bodyPr wrap="square" anchor="ctr" lIns="0" rIns="0" tIns="0" bIns="0">
-            <a:spAutoFit/>
-          </a:bodyPr>
-          <a:lstStyle/>
-          <a:p>
-            <a:pPr algn="ctr"/>
-            <a:r>
-              <a:rPr sz="3000" b="1">
-                <a:solidFill>
-                  <a:srgbClr val="1A2332"/>
-                </a:solidFill>
-                <a:latin typeface="Segoe UI"/>
-              </a:rPr>
-              <a:t>4%</a:t>
-            </a:r>
-          </a:p>
-        </p:txBody>
-      </p:sp>
-      <p:sp>
-        <p:nvSpPr>
-          <p:cNvPr id="21" name="TextBox 20"/>
-          <p:cNvSpPr txBox="1"/>
-          <p:nvPr/>
-        </p:nvSpPr>
-        <p:spPr>
-          <a:xfrm>
-            <a:off x="5095036" y="3172968"/>
-            <a:ext cx="1998878" cy="320040"/>
-          </a:xfrm>
-          <a:prstGeom prst="rect">
-            <a:avLst/>
-          </a:prstGeom>
-          <a:noFill/>
-        </p:spPr>
-        <p:txBody>
-          <a:bodyPr wrap="square" anchor="ctr" lIns="0" rIns="0" tIns="0" bIns="0">
-            <a:spAutoFit/>
-          </a:bodyPr>
-          <a:lstStyle/>
-          <a:p>
-            <a:pPr algn="ctr"/>
-            <a:r>
-              <a:rPr sz="1200" b="0">
-                <a:solidFill>
-                  <a:srgbClr val="5E665E"/>
-                </a:solidFill>
-                <a:latin typeface="Segoe UI"/>
-              </a:rPr>
-              <a:t>target 30%</a:t>
-            </a:r>
-          </a:p>
-        </p:txBody>
-      </p:sp>
-      <p:sp>
-        <p:nvSpPr>
-          <p:cNvPr id="22" name="Rounded Rectangle 21"/>
-          <p:cNvSpPr/>
-          <p:nvPr/>
-        </p:nvSpPr>
-        <p:spPr>
-          <a:xfrm>
-            <a:off x="7322515" y="1874519"/>
-            <a:ext cx="1998878" cy="1691640"/>
-          </a:xfrm>
-          <a:prstGeom prst="roundRect">
-            <a:avLst/>
-          </a:prstGeom>
-          <a:solidFill>
-            <a:srgbClr val="EFF1EC"/>
-          </a:solidFill>
-          <a:ln w="9525">
-            <a:solidFill>
-              <a:srgbClr val="D8DDD4"/>
-            </a:solidFill>
-          </a:ln>
-          <a:effectLst/>
-        </p:spPr>
-        <p:style>
-          <a:lnRef idx="1">
-            <a:schemeClr val="accent1"/>
-          </a:lnRef>
-          <a:fillRef idx="3">
-            <a:schemeClr val="accent1"/>
-          </a:fillRef>
-          <a:effectRef idx="2">
-            <a:schemeClr val="accent1"/>
-          </a:effectRef>
-          <a:fontRef idx="minor">
-            <a:schemeClr val="lt1"/>
-          </a:fontRef>
-        </p:style>
-        <p:txBody>
-          <a:bodyPr rtlCol="0" anchor="ctr"/>
-          <a:lstStyle/>
-          <a:p>
-            <a:pPr algn="ctr"/>
-          </a:p>
-        </p:txBody>
-      </p:sp>
-      <p:sp>
-        <p:nvSpPr>
-          <p:cNvPr id="23" name="TextBox 22"/>
-          <p:cNvSpPr txBox="1"/>
-          <p:nvPr/>
-        </p:nvSpPr>
-        <p:spPr>
-          <a:xfrm>
-            <a:off x="7322515" y="2075688"/>
-            <a:ext cx="1998878" cy="365760"/>
-          </a:xfrm>
-          <a:prstGeom prst="rect">
-            <a:avLst/>
-          </a:prstGeom>
-          <a:noFill/>
-        </p:spPr>
-        <p:txBody>
-          <a:bodyPr wrap="square" anchor="ctr" lIns="0" rIns="0" tIns="0" bIns="0">
-            <a:spAutoFit/>
-          </a:bodyPr>
-          <a:lstStyle/>
-          <a:p>
-            <a:pPr algn="ctr"/>
-            <a:r>
-              <a:rPr sz="1350" b="1">
-                <a:solidFill>
-                  <a:srgbClr val="5E665E"/>
-                </a:solidFill>
-                <a:latin typeface="Segoe UI"/>
-              </a:rPr>
-              <a:t>Pricing</a:t>
-            </a:r>
-          </a:p>
-        </p:txBody>
-      </p:sp>
-      <p:sp>
-        <p:nvSpPr>
-          <p:cNvPr id="24" name="Rounded Rectangle 23"/>
-          <p:cNvSpPr/>
-          <p:nvPr/>
-        </p:nvSpPr>
-        <p:spPr>
-          <a:xfrm>
-            <a:off x="7887614" y="2441448"/>
-            <a:ext cx="868680" cy="64008"/>
-          </a:xfrm>
-          <a:prstGeom prst="roundRect">
-            <a:avLst/>
-          </a:prstGeom>
-          <a:solidFill>
-            <a:srgbClr val="29A9E1"/>
-          </a:solidFill>
-          <a:ln>
-            <a:noFill/>
-          </a:ln>
-          <a:effectLst/>
-        </p:spPr>
-        <p:style>
-          <a:lnRef idx="1">
-            <a:schemeClr val="accent1"/>
-          </a:lnRef>
-          <a:fillRef idx="3">
-            <a:schemeClr val="accent1"/>
-          </a:fillRef>
-          <a:effectRef idx="2">
-            <a:schemeClr val="accent1"/>
-          </a:effectRef>
-          <a:fontRef idx="minor">
-            <a:schemeClr val="lt1"/>
-          </a:fontRef>
-        </p:style>
-        <p:txBody>
-          <a:bodyPr rtlCol="0" anchor="ctr"/>
-          <a:lstStyle/>
-          <a:p>
-            <a:pPr algn="ctr"/>
-          </a:p>
-        </p:txBody>
-      </p:sp>
-      <p:sp>
-        <p:nvSpPr>
-          <p:cNvPr id="25" name="TextBox 24"/>
-          <p:cNvSpPr txBox="1"/>
-          <p:nvPr/>
-        </p:nvSpPr>
-        <p:spPr>
-          <a:xfrm>
-            <a:off x="7322515" y="2587752"/>
-            <a:ext cx="1998878" cy="548640"/>
-          </a:xfrm>
-          <a:prstGeom prst="rect">
-            <a:avLst/>
-          </a:prstGeom>
-          <a:noFill/>
-        </p:spPr>
-        <p:txBody>
-          <a:bodyPr wrap="square" anchor="ctr" lIns="0" rIns="0" tIns="0" bIns="0">
-            <a:spAutoFit/>
-          </a:bodyPr>
-          <a:lstStyle/>
-          <a:p>
-            <a:pPr algn="ctr"/>
-            <a:r>
-              <a:rPr sz="3000" b="1">
-                <a:solidFill>
-                  <a:srgbClr val="1A2332"/>
-                </a:solidFill>
-                <a:latin typeface="Segoe UI"/>
-              </a:rPr>
-              <a:t>79%</a:t>
-            </a:r>
-          </a:p>
-        </p:txBody>
-      </p:sp>
-      <p:sp>
-        <p:nvSpPr>
-          <p:cNvPr id="26" name="TextBox 25"/>
-          <p:cNvSpPr txBox="1"/>
-          <p:nvPr/>
-        </p:nvSpPr>
-        <p:spPr>
-          <a:xfrm>
-            <a:off x="7322515" y="3172968"/>
-            <a:ext cx="1998878" cy="320040"/>
-          </a:xfrm>
-          <a:prstGeom prst="rect">
-            <a:avLst/>
-          </a:prstGeom>
-          <a:noFill/>
-        </p:spPr>
-        <p:txBody>
-          <a:bodyPr wrap="square" anchor="ctr" lIns="0" rIns="0" tIns="0" bIns="0">
-            <a:spAutoFit/>
-          </a:bodyPr>
-          <a:lstStyle/>
-          <a:p>
-            <a:pPr algn="ctr"/>
-            <a:r>
-              <a:rPr sz="1200" b="0">
-                <a:solidFill>
-                  <a:srgbClr val="5E665E"/>
-                </a:solidFill>
-                <a:latin typeface="Segoe UI"/>
-              </a:rPr>
-              <a:t>target 100%</a:t>
-            </a:r>
-          </a:p>
-        </p:txBody>
-      </p:sp>
-      <p:sp>
-        <p:nvSpPr>
-          <p:cNvPr id="27" name="Rounded Rectangle 26"/>
-          <p:cNvSpPr/>
-          <p:nvPr/>
-        </p:nvSpPr>
-        <p:spPr>
-          <a:xfrm>
-            <a:off x="9549993" y="1874519"/>
-            <a:ext cx="1998878" cy="1691640"/>
-          </a:xfrm>
-          <a:prstGeom prst="roundRect">
-            <a:avLst/>
-          </a:prstGeom>
-          <a:solidFill>
-            <a:srgbClr val="EFF1EC"/>
-          </a:solidFill>
-          <a:ln w="9525">
-            <a:solidFill>
-              <a:srgbClr val="D8DDD4"/>
-            </a:solidFill>
-          </a:ln>
-          <a:effectLst/>
-        </p:spPr>
-        <p:style>
-          <a:lnRef idx="1">
-            <a:schemeClr val="accent1"/>
-          </a:lnRef>
-          <a:fillRef idx="3">
-            <a:schemeClr val="accent1"/>
-          </a:fillRef>
-          <a:effectRef idx="2">
-            <a:schemeClr val="accent1"/>
-          </a:effectRef>
-          <a:fontRef idx="minor">
-            <a:schemeClr val="lt1"/>
-          </a:fontRef>
-        </p:style>
-        <p:txBody>
-          <a:bodyPr rtlCol="0" anchor="ctr"/>
-          <a:lstStyle/>
-          <a:p>
-            <a:pPr algn="ctr"/>
-          </a:p>
-        </p:txBody>
-      </p:sp>
-      <p:sp>
-        <p:nvSpPr>
-          <p:cNvPr id="28" name="TextBox 27"/>
-          <p:cNvSpPr txBox="1"/>
-          <p:nvPr/>
-        </p:nvSpPr>
-        <p:spPr>
-          <a:xfrm>
-            <a:off x="9549993" y="2075688"/>
-            <a:ext cx="1998878" cy="365760"/>
-          </a:xfrm>
-          <a:prstGeom prst="rect">
-            <a:avLst/>
-          </a:prstGeom>
-          <a:noFill/>
-        </p:spPr>
-        <p:txBody>
-          <a:bodyPr wrap="square" anchor="ctr" lIns="0" rIns="0" tIns="0" bIns="0">
-            <a:spAutoFit/>
-          </a:bodyPr>
-          <a:lstStyle/>
-          <a:p>
-            <a:pPr algn="ctr"/>
-            <a:r>
-              <a:rPr sz="1350" b="1">
-                <a:solidFill>
-                  <a:srgbClr val="5E665E"/>
-                </a:solidFill>
-                <a:latin typeface="Segoe UI"/>
-              </a:rPr>
-              <a:t>Self-gen</a:t>
-            </a:r>
-          </a:p>
-        </p:txBody>
-      </p:sp>
-      <p:sp>
-        <p:nvSpPr>
-          <p:cNvPr id="29" name="Rounded Rectangle 28"/>
-          <p:cNvSpPr/>
-          <p:nvPr/>
-        </p:nvSpPr>
-        <p:spPr>
-          <a:xfrm>
-            <a:off x="10115092" y="2441448"/>
-            <a:ext cx="868680" cy="64008"/>
-          </a:xfrm>
-          <a:prstGeom prst="roundRect">
-            <a:avLst/>
-          </a:prstGeom>
-          <a:solidFill>
-            <a:srgbClr val="29A9E1"/>
-          </a:solidFill>
-          <a:ln>
-            <a:noFill/>
-          </a:ln>
-          <a:effectLst/>
-        </p:spPr>
-        <p:style>
-          <a:lnRef idx="1">
-            <a:schemeClr val="accent1"/>
-          </a:lnRef>
-          <a:fillRef idx="3">
-            <a:schemeClr val="accent1"/>
-          </a:fillRef>
-          <a:effectRef idx="2">
-            <a:schemeClr val="accent1"/>
-          </a:effectRef>
-          <a:fontRef idx="minor">
-            <a:schemeClr val="lt1"/>
-          </a:fontRef>
-        </p:style>
-        <p:txBody>
-          <a:bodyPr rtlCol="0" anchor="ctr"/>
-          <a:lstStyle/>
-          <a:p>
-            <a:pPr algn="ctr"/>
-          </a:p>
-        </p:txBody>
-      </p:sp>
-      <p:sp>
-        <p:nvSpPr>
-          <p:cNvPr id="30" name="TextBox 29"/>
-          <p:cNvSpPr txBox="1"/>
-          <p:nvPr/>
-        </p:nvSpPr>
-        <p:spPr>
-          <a:xfrm>
-            <a:off x="9549993" y="2587752"/>
-            <a:ext cx="1998878" cy="548640"/>
-          </a:xfrm>
-          <a:prstGeom prst="rect">
-            <a:avLst/>
-          </a:prstGeom>
-          <a:noFill/>
-        </p:spPr>
-        <p:txBody>
-          <a:bodyPr wrap="square" anchor="ctr" lIns="0" rIns="0" tIns="0" bIns="0">
-            <a:spAutoFit/>
-          </a:bodyPr>
-          <a:lstStyle/>
-          <a:p>
-            <a:pPr algn="ctr"/>
-            <a:r>
-              <a:rPr sz="3000" b="1">
-                <a:solidFill>
-                  <a:srgbClr val="1A2332"/>
-                </a:solidFill>
-                <a:latin typeface="Segoe UI"/>
-              </a:rPr>
-              <a:t>22%</a:t>
-            </a:r>
-          </a:p>
-        </p:txBody>
-      </p:sp>
-      <p:sp>
-        <p:nvSpPr>
-          <p:cNvPr id="31" name="TextBox 30"/>
-          <p:cNvSpPr txBox="1"/>
-          <p:nvPr/>
-        </p:nvSpPr>
-        <p:spPr>
-          <a:xfrm>
-            <a:off x="9549993" y="3172968"/>
-            <a:ext cx="1998878" cy="320040"/>
-          </a:xfrm>
-          <a:prstGeom prst="rect">
-            <a:avLst/>
-          </a:prstGeom>
-          <a:noFill/>
-        </p:spPr>
-        <p:txBody>
-          <a:bodyPr wrap="square" anchor="ctr" lIns="0" rIns="0" tIns="0" bIns="0">
-            <a:spAutoFit/>
-          </a:bodyPr>
-          <a:lstStyle/>
-          <a:p>
-            <a:pPr algn="ctr"/>
-            <a:r>
-              <a:rPr sz="1200" b="0">
-                <a:solidFill>
-                  <a:srgbClr val="5E665E"/>
-                </a:solidFill>
-                <a:latin typeface="Segoe UI"/>
-              </a:rPr>
-              <a:t>target 75%</a:t>
-            </a:r>
-          </a:p>
-        </p:txBody>
-      </p:sp>
-      <p:sp>
-        <p:nvSpPr>
-          <p:cNvPr id="32" name="TextBox 31"/>
-          <p:cNvSpPr txBox="1"/>
-          <p:nvPr/>
-        </p:nvSpPr>
-        <p:spPr>
-          <a:xfrm>
-            <a:off x="640080" y="3611879"/>
-            <a:ext cx="10908792" cy="320040"/>
-          </a:xfrm>
-          <a:prstGeom prst="rect">
-            <a:avLst/>
-          </a:prstGeom>
-          <a:noFill/>
-        </p:spPr>
-        <p:txBody>
-          <a:bodyPr wrap="square" anchor="t" lIns="0" rIns="0" tIns="0" bIns="0">
-            <a:spAutoFit/>
-          </a:bodyPr>
-          <a:lstStyle/>
-          <a:p>
-            <a:pPr algn="ctr"/>
-            <a:r>
-              <a:rPr sz="1250" b="0">
-                <a:solidFill>
-                  <a:srgbClr val="5E665E"/>
-                </a:solidFill>
-                <a:latin typeface="Segoe UI"/>
-              </a:rPr>
-              <a:t>Each number is scored against its target, then weighted. Near target on the big two is what carries the score.</a:t>
-            </a:r>
-          </a:p>
-        </p:txBody>
-      </p:sp>
-      <p:sp>
-        <p:nvSpPr>
-          <p:cNvPr id="33" name="Rounded Rectangle 32"/>
-          <p:cNvSpPr/>
-          <p:nvPr/>
-        </p:nvSpPr>
-        <p:spPr>
-          <a:xfrm>
-            <a:off x="640080" y="4160520"/>
-            <a:ext cx="10908792" cy="960120"/>
-          </a:xfrm>
-          <a:prstGeom prst="roundRect">
-            <a:avLst/>
-          </a:prstGeom>
-          <a:solidFill>
-            <a:srgbClr val="1A2332"/>
-          </a:solidFill>
-          <a:ln>
-            <a:noFill/>
-          </a:ln>
-          <a:effectLst/>
-        </p:spPr>
-        <p:style>
-          <a:lnRef idx="1">
-            <a:schemeClr val="accent1"/>
-          </a:lnRef>
-          <a:fillRef idx="3">
-            <a:schemeClr val="accent1"/>
-          </a:fillRef>
-          <a:effectRef idx="2">
-            <a:schemeClr val="accent1"/>
-          </a:effectRef>
-          <a:fontRef idx="minor">
-            <a:schemeClr val="lt1"/>
-          </a:fontRef>
-        </p:style>
-        <p:txBody>
-          <a:bodyPr rtlCol="0" anchor="ctr"/>
-          <a:lstStyle/>
-          <a:p>
-            <a:pPr algn="ctr"/>
-          </a:p>
-        </p:txBody>
-      </p:sp>
-      <p:sp>
-        <p:nvSpPr>
-          <p:cNvPr id="34" name="TextBox 33"/>
-          <p:cNvSpPr txBox="1"/>
-          <p:nvPr/>
-        </p:nvSpPr>
-        <p:spPr>
-          <a:xfrm>
-            <a:off x="1097280" y="4160520"/>
-            <a:ext cx="4572000" cy="960120"/>
-          </a:xfrm>
-          <a:prstGeom prst="rect">
-            <a:avLst/>
-          </a:prstGeom>
-          <a:noFill/>
-        </p:spPr>
-        <p:txBody>
-          <a:bodyPr wrap="square" anchor="ctr" lIns="0" rIns="0" tIns="0" bIns="0">
-            <a:spAutoFit/>
-          </a:bodyPr>
-          <a:lstStyle/>
-          <a:p>
-            <a:pPr algn="l"/>
-            <a:r>
-              <a:rPr sz="1800" b="0">
-                <a:solidFill>
-                  <a:srgbClr val="C9D2C4"/>
-                </a:solidFill>
-                <a:latin typeface="Segoe UI"/>
-              </a:rPr>
-              <a:t>Viper score   </a:t>
-            </a:r>
-            <a:r>
-              <a:rPr sz="4000" b="1">
-                <a:solidFill>
-                  <a:srgbClr val="FFFFFF"/>
-                </a:solidFill>
-                <a:latin typeface="Segoe UI"/>
-              </a:rPr>
-              <a:t>79</a:t>
-            </a:r>
-          </a:p>
-        </p:txBody>
-      </p:sp>
-      <p:sp>
-        <p:nvSpPr>
-          <p:cNvPr id="35" name="Rounded Rectangle 34"/>
-          <p:cNvSpPr/>
-          <p:nvPr/>
-        </p:nvSpPr>
-        <p:spPr>
-          <a:xfrm>
-            <a:off x="6766560" y="4343400"/>
-            <a:ext cx="2011680" cy="594360"/>
-          </a:xfrm>
-          <a:prstGeom prst="roundRect">
-            <a:avLst/>
-          </a:prstGeom>
-          <a:solidFill>
-            <a:srgbClr val="5EBA28"/>
-          </a:solidFill>
-          <a:ln>
-            <a:noFill/>
-          </a:ln>
-          <a:effectLst/>
-        </p:spPr>
-        <p:style>
-          <a:lnRef idx="1">
-            <a:schemeClr val="accent1"/>
-          </a:lnRef>
-          <a:fillRef idx="3">
-            <a:schemeClr val="accent1"/>
-          </a:fillRef>
-          <a:effectRef idx="2">
-            <a:schemeClr val="accent1"/>
-          </a:effectRef>
-          <a:fontRef idx="minor">
-            <a:schemeClr val="lt1"/>
-          </a:fontRef>
-        </p:style>
-        <p:txBody>
-          <a:bodyPr rtlCol="0" anchor="ctr"/>
-          <a:lstStyle/>
-          <a:p>
-            <a:pPr algn="ctr"/>
-          </a:p>
-        </p:txBody>
-      </p:sp>
-      <p:sp>
-        <p:nvSpPr>
-          <p:cNvPr id="36" name="TextBox 35"/>
-          <p:cNvSpPr txBox="1"/>
-          <p:nvPr/>
-        </p:nvSpPr>
-        <p:spPr>
-          <a:xfrm>
-            <a:off x="6766560" y="4343400"/>
-            <a:ext cx="2011680" cy="594360"/>
-          </a:xfrm>
-          <a:prstGeom prst="rect">
-            <a:avLst/>
-          </a:prstGeom>
-          <a:noFill/>
-        </p:spPr>
-        <p:txBody>
-          <a:bodyPr wrap="square" anchor="ctr" lIns="0" rIns="0" tIns="0" bIns="0">
-            <a:spAutoFit/>
-          </a:bodyPr>
-          <a:lstStyle/>
-          <a:p>
-            <a:pPr algn="ctr"/>
-            <a:r>
-              <a:rPr sz="2400" b="1">
-                <a:solidFill>
-                  <a:srgbClr val="FFFFFF"/>
-                </a:solidFill>
-                <a:latin typeface="Segoe UI"/>
-              </a:rPr>
-              <a:t>Rank 4</a:t>
-            </a:r>
-          </a:p>
-        </p:txBody>
-      </p:sp>
-      <p:sp>
-        <p:nvSpPr>
-          <p:cNvPr id="37" name="TextBox 36"/>
-          <p:cNvSpPr txBox="1"/>
-          <p:nvPr/>
-        </p:nvSpPr>
-        <p:spPr>
-          <a:xfrm>
-            <a:off x="8961119" y="4160520"/>
-            <a:ext cx="2468880" cy="960120"/>
-          </a:xfrm>
-          <a:prstGeom prst="rect">
-            <a:avLst/>
-          </a:prstGeom>
-          <a:noFill/>
-        </p:spPr>
-        <p:txBody>
-          <a:bodyPr wrap="square" anchor="ctr" lIns="0" rIns="0" tIns="0" bIns="0">
-            <a:spAutoFit/>
-          </a:bodyPr>
-          <a:lstStyle/>
-          <a:p>
-            <a:pPr algn="l">
-              <a:spcAft>
-                <a:spcPts val="200"/>
-              </a:spcAft>
-            </a:pPr>
-            <a:r>
-              <a:rPr sz="1600" b="1">
-                <a:solidFill>
-                  <a:srgbClr val="FFFFFF"/>
-                </a:solidFill>
-                <a:latin typeface="Segoe UI"/>
-              </a:rPr>
-              <a:t>up from 3</a:t>
-            </a:r>
-          </a:p>
-          <a:p>
-            <a:pPr algn="l">
-              <a:spcAft>
-                <a:spcPts val="200"/>
-              </a:spcAft>
-            </a:pPr>
-            <a:r>
-              <a:rPr sz="1250" b="0">
-                <a:solidFill>
-                  <a:srgbClr val="C9D2C4"/>
-                </a:solidFill>
-                <a:latin typeface="Segoe UI"/>
-              </a:rPr>
-              <a:t>the week before</a:t>
-            </a:r>
-          </a:p>
-        </p:txBody>
-      </p:sp>
-      <p:sp>
-        <p:nvSpPr>
-          <p:cNvPr id="38" name="TextBox 37"/>
-          <p:cNvSpPr txBox="1"/>
-          <p:nvPr/>
-        </p:nvSpPr>
-        <p:spPr>
-          <a:xfrm>
-            <a:off x="640080" y="5349240"/>
-            <a:ext cx="10908792" cy="457200"/>
-          </a:xfrm>
-          <a:prstGeom prst="rect">
-            <a:avLst/>
-          </a:prstGeom>
-          <a:noFill/>
-        </p:spPr>
-        <p:txBody>
-          <a:bodyPr wrap="square" anchor="t" lIns="0" rIns="0" tIns="0" bIns="0">
-            <a:spAutoFit/>
-          </a:bodyPr>
-          <a:lstStyle/>
-          <a:p>
-            <a:pPr algn="ctr"/>
-            <a:r>
-              <a:rPr sz="1500" b="1">
-                <a:solidFill>
-                  <a:srgbClr val="1A2332"/>
-                </a:solidFill>
-                <a:latin typeface="Segoe UI"/>
-              </a:rPr>
-              <a:t>Closes and installs our leads well, which is the 80% that counts. Attachment is the gap. Net: a solid rank 4.</a:t>
-            </a:r>
-          </a:p>
-        </p:txBody>
-      </p:sp>
-      <p:sp>
-        <p:nvSpPr>
-          <p:cNvPr id="39" name="Rounded Rectangle 38"/>
-          <p:cNvSpPr/>
-          <p:nvPr/>
-        </p:nvSpPr>
-        <p:spPr>
-          <a:xfrm>
-            <a:off x="640080" y="5989320"/>
-            <a:ext cx="10908792" cy="548640"/>
-          </a:xfrm>
-          <a:prstGeom prst="roundRect">
-            <a:avLst/>
-          </a:prstGeom>
-          <a:solidFill>
-            <a:srgbClr val="EFF1EC"/>
-          </a:solidFill>
-          <a:ln w="9525">
-            <a:solidFill>
-              <a:srgbClr val="D8DDD4"/>
-            </a:solidFill>
-          </a:ln>
-          <a:effectLst/>
-        </p:spPr>
-        <p:style>
-          <a:lnRef idx="1">
-            <a:schemeClr val="accent1"/>
-          </a:lnRef>
-          <a:fillRef idx="3">
-            <a:schemeClr val="accent1"/>
-          </a:fillRef>
-          <a:effectRef idx="2">
-            <a:schemeClr val="accent1"/>
-          </a:effectRef>
-          <a:fontRef idx="minor">
-            <a:schemeClr val="lt1"/>
-          </a:fontRef>
-        </p:style>
-        <p:txBody>
-          <a:bodyPr rtlCol="0" anchor="ctr"/>
-          <a:lstStyle/>
-          <a:p>
-            <a:pPr algn="ctr"/>
-          </a:p>
-        </p:txBody>
-      </p:sp>
-      <p:sp>
-        <p:nvSpPr>
-          <p:cNvPr id="40" name="TextBox 39"/>
-          <p:cNvSpPr txBox="1"/>
-          <p:nvPr/>
-        </p:nvSpPr>
-        <p:spPr>
-          <a:xfrm>
-            <a:off x="914400" y="5989320"/>
-            <a:ext cx="10360152" cy="548640"/>
-          </a:xfrm>
-          <a:prstGeom prst="rect">
-            <a:avLst/>
-          </a:prstGeom>
-          <a:noFill/>
-        </p:spPr>
-        <p:txBody>
-          <a:bodyPr wrap="square" anchor="ctr" lIns="0" rIns="0" tIns="0" bIns="0">
-            <a:spAutoFit/>
-          </a:bodyPr>
-          <a:lstStyle/>
-          <a:p>
-            <a:pPr algn="l"/>
-            <a:r>
-              <a:rPr sz="1200" b="0">
-                <a:solidFill>
-                  <a:srgbClr val="5E665E"/>
-                </a:solidFill>
-                <a:latin typeface="Segoe UI"/>
-              </a:rPr>
-              <a:t>Latest run: dispatched appointments read Mar 7 to May 22, installs measured on deals signed Jun 2025 to Feb 2026.</a:t>
-            </a:r>
-          </a:p>
-        </p:txBody>
-      </p:sp>
-    </p:spTree>
-  </p:cSld>
-  <p:clrMapOvr>
-    <a:masterClrMapping/>
-  </p:clrMapOvr>
-</p:sld>
-</file>
-
-<file path=ppt/slides/slide15.xml><?xml version="1.0" encoding="utf-8"?>
-<p:sld xmlns:a="http://schemas.openxmlformats.org/drawingml/2006/main" xmlns:p="http://schemas.openxmlformats.org/presentationml/2006/main" xmlns:r="http://schemas.openxmlformats.org/officeDocument/2006/relationships">
-  <p:cSld>
-    <p:spTree>
-      <p:nvGrpSpPr>
-        <p:cNvPr id="1" name=""/>
-        <p:cNvGrpSpPr/>
-        <p:nvPr/>
-      </p:nvGrpSpPr>
-      <p:grpSpPr/>
-      <p:sp>
-        <p:nvSpPr>
-          <p:cNvPr id="2" name="Rectangle 1"/>
-          <p:cNvSpPr/>
-          <p:nvPr/>
-        </p:nvSpPr>
-        <p:spPr>
-          <a:xfrm>
-            <a:off x="0" y="0"/>
-            <a:ext cx="12191695" cy="6858000"/>
-          </a:xfrm>
-          <a:prstGeom prst="rect">
-            <a:avLst/>
-          </a:prstGeom>
-          <a:solidFill>
-            <a:srgbClr val="FFFFFF"/>
-          </a:solidFill>
-          <a:ln>
-            <a:noFill/>
-          </a:ln>
-          <a:effectLst/>
-        </p:spPr>
-        <p:style>
-          <a:lnRef idx="1">
-            <a:schemeClr val="accent1"/>
-          </a:lnRef>
-          <a:fillRef idx="3">
-            <a:schemeClr val="accent1"/>
-          </a:fillRef>
-          <a:effectRef idx="2">
-            <a:schemeClr val="accent1"/>
-          </a:effectRef>
-          <a:fontRef idx="minor">
-            <a:schemeClr val="lt1"/>
-          </a:fontRef>
-        </p:style>
-        <p:txBody>
-          <a:bodyPr rtlCol="0" anchor="ctr"/>
-          <a:lstStyle/>
-          <a:p>
-            <a:pPr algn="ctr"/>
-          </a:p>
-        </p:txBody>
-      </p:sp>
-      <p:sp>
-        <p:nvSpPr>
-          <p:cNvPr id="3" name="Rectangle 2"/>
-          <p:cNvSpPr/>
-          <p:nvPr/>
-        </p:nvSpPr>
-        <p:spPr>
-          <a:xfrm>
-            <a:off x="0" y="0"/>
-            <a:ext cx="12191695" cy="1005840"/>
-          </a:xfrm>
-          <a:prstGeom prst="rect">
-            <a:avLst/>
-          </a:prstGeom>
-          <a:solidFill>
-            <a:srgbClr val="1A2332"/>
-          </a:solidFill>
-          <a:ln>
-            <a:noFill/>
-          </a:ln>
-          <a:effectLst/>
-        </p:spPr>
-        <p:style>
-          <a:lnRef idx="1">
-            <a:schemeClr val="accent1"/>
-          </a:lnRef>
-          <a:fillRef idx="3">
-            <a:schemeClr val="accent1"/>
-          </a:fillRef>
-          <a:effectRef idx="2">
-            <a:schemeClr val="accent1"/>
-          </a:effectRef>
-          <a:fontRef idx="minor">
-            <a:schemeClr val="lt1"/>
-          </a:fontRef>
-        </p:style>
-        <p:txBody>
-          <a:bodyPr rtlCol="0" anchor="ctr"/>
-          <a:lstStyle/>
-          <a:p>
-            <a:pPr algn="ctr"/>
-          </a:p>
-        </p:txBody>
-      </p:sp>
-      <p:sp>
-        <p:nvSpPr>
-          <p:cNvPr id="4" name="Rectangle 3"/>
-          <p:cNvSpPr/>
-          <p:nvPr/>
-        </p:nvSpPr>
-        <p:spPr>
-          <a:xfrm>
-            <a:off x="0" y="1005840"/>
-            <a:ext cx="12191695" cy="73152"/>
-          </a:xfrm>
-          <a:prstGeom prst="rect">
-            <a:avLst/>
-          </a:prstGeom>
-          <a:solidFill>
-            <a:srgbClr val="5EBA28"/>
-          </a:solidFill>
-          <a:ln>
-            <a:noFill/>
-          </a:ln>
-          <a:effectLst/>
-        </p:spPr>
-        <p:style>
-          <a:lnRef idx="1">
-            <a:schemeClr val="accent1"/>
-          </a:lnRef>
-          <a:fillRef idx="3">
-            <a:schemeClr val="accent1"/>
-          </a:fillRef>
-          <a:effectRef idx="2">
-            <a:schemeClr val="accent1"/>
-          </a:effectRef>
-          <a:fontRef idx="minor">
-            <a:schemeClr val="lt1"/>
-          </a:fontRef>
-        </p:style>
-        <p:txBody>
-          <a:bodyPr rtlCol="0" anchor="ctr"/>
-          <a:lstStyle/>
-          <a:p>
-            <a:pPr algn="ctr"/>
-          </a:p>
-        </p:txBody>
-      </p:sp>
-      <p:sp>
-        <p:nvSpPr>
-          <p:cNvPr id="5" name="TextBox 4"/>
-          <p:cNvSpPr txBox="1"/>
-          <p:nvPr/>
-        </p:nvSpPr>
-        <p:spPr>
-          <a:xfrm>
-            <a:off x="640080" y="0"/>
-            <a:ext cx="10972800" cy="1005840"/>
-          </a:xfrm>
-          <a:prstGeom prst="rect">
-            <a:avLst/>
-          </a:prstGeom>
-          <a:noFill/>
-        </p:spPr>
-        <p:txBody>
-          <a:bodyPr wrap="square" anchor="ctr" lIns="0" rIns="0" tIns="0" bIns="0">
-            <a:spAutoFit/>
-          </a:bodyPr>
-          <a:lstStyle/>
-          <a:p>
-            <a:pPr algn="l"/>
-            <a:r>
-              <a:rPr sz="2600" b="1">
-                <a:solidFill>
-                  <a:srgbClr val="FFFFFF"/>
-                </a:solidFill>
-                <a:latin typeface="Segoe UI"/>
-              </a:rPr>
               <a:t>Why it's steadier than before</a:t>
             </a:r>
           </a:p>
@@ -15903,7 +15197,7 @@
                 </a:solidFill>
                 <a:latin typeface="Segoe UI"/>
               </a:rPr>
-              <a:t>Do you bring in your own deals?</a:t>
+              <a:t>Do you bring in self-gen and referral deals?</a:t>
             </a:r>
           </a:p>
         </p:txBody>
@@ -17685,7 +16979,7 @@
                 </a:solidFill>
                 <a:latin typeface="Segoe UI"/>
               </a:rPr>
-              <a:t>Your own deals</a:t>
+              <a:t>Self-gen and referral deals</a:t>
             </a:r>
           </a:p>
         </p:txBody>
@@ -20251,7 +19545,7 @@
                 </a:solidFill>
                 <a:latin typeface="Segoe UI"/>
               </a:rPr>
-              <a:t>Before the timelines, three ground rules.</a:t>
+              <a:t>Three ground rules.</a:t>
             </a:r>
           </a:p>
         </p:txBody>
@@ -20396,7 +19690,7 @@
                 </a:solidFill>
                 <a:latin typeface="Segoe UI"/>
               </a:rPr>
-              <a:t>Your score is about the appointments we hand you. Self-gen is the one exception, and it only feeds its own 5%.</a:t>
+              <a:t>Your score is about the appointments we hand you. Self-gen and referral are the one exception, feeding only their own 5%.</a:t>
             </a:r>
           </a:p>
         </p:txBody>
@@ -20525,7 +19819,7 @@
                 </a:solidFill>
                 <a:latin typeface="Segoe UI"/>
               </a:rPr>
-              <a:t>A strike is a real at-bat</a:t>
+              <a:t>Dispatched appointments</a:t>
             </a:r>
           </a:p>
           <a:p>
@@ -20541,7 +19835,7 @@
                 </a:solidFill>
                 <a:latin typeface="Segoe UI"/>
               </a:rPr>
-              <a:t>An appointment where someone was home. Verified no-shows and disqualified leads (DQs) don't count for you or against you.</a:t>
+              <a:t>Every appointment we gave you, minus DQs and verified homeowner no-shows. A rep no-show or a cancel at the door still counts against you.</a:t>
             </a:r>
           </a:p>
         </p:txBody>
@@ -20670,7 +19964,7 @@
                 </a:solidFill>
                 <a:latin typeface="Segoe UI"/>
               </a:rPr>
-              <a:t>Measured inside your lane</a:t>
+              <a:t>A level playing field</a:t>
             </a:r>
           </a:p>
           <a:p>
@@ -20686,7 +19980,7 @@
                 </a:solidFill>
                 <a:latin typeface="Segoe UI"/>
               </a:rPr>
-              <a:t>Direct, Traditional, and Inside Sales each have their own bar, and you're ranked against your own region and division.</a:t>
+              <a:t>Viper removed the lanes. You're ranked against every rep in the regions you run, regardless of sales channel.</a:t>
             </a:r>
           </a:p>
         </p:txBody>

</xml_diff>

<commit_message>
Viper deck: revert multi-region line to general (regionals note was about resource access, not the rule)
Co-Authored-By: Claude Opus 4.8 <noreply@anthropic.com>
</commit_message>
<xml_diff>
--- a/management/viper-ranking-overview.pptx
+++ b/management/viper-ranking-overview.pptx
@@ -655,7 +655,7 @@
           <a:lstStyle/>
           <a:p>
             <a:r>
-              <a:t>How your score becomes your rank. Your pool is your region, no sales channel, everyone in the region together. Inside it, the highest scores earn the highest ranks. Regionals and above who cover several regions keep the best rank they earn. It rebalances weekly, so a 4 means the same thing across the company. For example, a 79 lands in the rank-4 tier.</a:t>
+              <a:t>How your score becomes your rank. Your pool is your region, no sales channel, everyone in the region together. Inside it, the highest scores earn the highest ranks. If you run leads in several regions, you keep the best rank you earn. It rebalances weekly, so a 4 means the same thing across the company. For example, a 79 lands in the rank-4 tier.</a:t>
             </a:r>
           </a:p>
         </p:txBody>
@@ -6479,7 +6479,7 @@
                 </a:solidFill>
                 <a:latin typeface="Segoe UI"/>
               </a:rPr>
-              <a:t>Regionals and above who cover several regions keep the highest rank they earn.</a:t>
+              <a:t>Run leads in several regions and you keep the highest rank you earn.</a:t>
             </a:r>
           </a:p>
         </p:txBody>

</xml_diff>